<commit_message>
feat: set up pandoc refs
</commit_message>
<xml_diff>
--- a/docs/figures/pptx/continuous-curation-loop.pptx
+++ b/docs/figures/pptx/continuous-curation-loop.pptx
@@ -5,11 +5,13 @@
     <p:sldMasterId id="2147483660" r:id="rId1"/>
   </p:sldMasterIdLst>
   <p:notesMasterIdLst>
-    <p:notesMasterId r:id="rId4"/>
+    <p:notesMasterId r:id="rId6"/>
   </p:notesMasterIdLst>
   <p:sldIdLst>
-    <p:sldId id="282" r:id="rId2"/>
-    <p:sldId id="283" r:id="rId3"/>
+    <p:sldId id="283" r:id="rId2"/>
+    <p:sldId id="282" r:id="rId3"/>
+    <p:sldId id="284" r:id="rId4"/>
+    <p:sldId id="285" r:id="rId5"/>
   </p:sldIdLst>
   <p:sldSz cx="7772400" cy="10058400"/>
   <p:notesSz cx="6858000" cy="9144000"/>
@@ -198,7 +200,7 @@
           <a:p>
             <a:fld id="{50F1E524-6E79-CF4B-9E85-0A88F03DEB7C}" type="datetimeFigureOut">
               <a:rPr lang="en-US" smtClean="0"/>
-              <a:t>9/18/26</a:t>
+              <a:t>9/20/26</a:t>
             </a:fld>
             <a:endParaRPr lang="en-US"/>
           </a:p>
@@ -530,7 +532,7 @@
           <a:p>
             <a:fld id="{C1D44131-5ABB-A944-8E26-DE05003D1682}" type="slidenum">
               <a:rPr lang="en-US" smtClean="0"/>
-              <a:t>1</a:t>
+              <a:t>2</a:t>
             </a:fld>
             <a:endParaRPr lang="en-US"/>
           </a:p>
@@ -2082,7 +2084,7 @@
           <a:p>
             <a:fld id="{F10855C1-EDC8-3D45-8F6E-152AA6BBBAFA}" type="datetimeFigureOut">
               <a:rPr lang="en-US" smtClean="0"/>
-              <a:t>9/18/26</a:t>
+              <a:t>9/20/26</a:t>
             </a:fld>
             <a:endParaRPr lang="en-US"/>
           </a:p>
@@ -5750,6 +5752,1740 @@
   <p:cSld>
     <p:spTree>
       <p:nvGrpSpPr>
+        <p:cNvPr id="1" name=""/>
+        <p:cNvGrpSpPr/>
+        <p:nvPr/>
+      </p:nvGrpSpPr>
+      <p:grpSpPr>
+        <a:xfrm>
+          <a:off x="0" y="0"/>
+          <a:ext cx="0" cy="0"/>
+          <a:chOff x="0" y="0"/>
+          <a:chExt cx="0" cy="0"/>
+        </a:xfrm>
+      </p:grpSpPr>
+      <p:grpSp>
+        <p:nvGrpSpPr>
+          <p:cNvPr id="3" name="Group 2">
+            <a:extLst>
+              <a:ext uri="{FF2B5EF4-FFF2-40B4-BE49-F238E27FC236}">
+                <a16:creationId xmlns:a16="http://schemas.microsoft.com/office/drawing/2014/main" id="{109A0B90-33B2-C40D-B1C1-9DBE50900565}"/>
+              </a:ext>
+            </a:extLst>
+          </p:cNvPr>
+          <p:cNvGrpSpPr/>
+          <p:nvPr/>
+        </p:nvGrpSpPr>
+        <p:grpSpPr>
+          <a:xfrm>
+            <a:off x="2010292" y="-48170"/>
+            <a:ext cx="3857403" cy="2277958"/>
+            <a:chOff x="444491" y="2336963"/>
+            <a:chExt cx="7183605" cy="4242220"/>
+          </a:xfrm>
+        </p:grpSpPr>
+        <p:grpSp>
+          <p:nvGrpSpPr>
+            <p:cNvPr id="4" name="Group 3">
+              <a:extLst>
+                <a:ext uri="{FF2B5EF4-FFF2-40B4-BE49-F238E27FC236}">
+                  <a16:creationId xmlns:a16="http://schemas.microsoft.com/office/drawing/2014/main" id="{761BC9F4-7F15-8504-DC01-85E189E3E022}"/>
+                </a:ext>
+              </a:extLst>
+            </p:cNvPr>
+            <p:cNvGrpSpPr/>
+            <p:nvPr/>
+          </p:nvGrpSpPr>
+          <p:grpSpPr>
+            <a:xfrm>
+              <a:off x="444491" y="2336963"/>
+              <a:ext cx="7183605" cy="4242220"/>
+              <a:chOff x="444491" y="2336963"/>
+              <a:chExt cx="7183605" cy="4242220"/>
+            </a:xfrm>
+          </p:grpSpPr>
+          <p:sp>
+            <p:nvSpPr>
+              <p:cNvPr id="11" name="Freeform 10">
+                <a:extLst>
+                  <a:ext uri="{FF2B5EF4-FFF2-40B4-BE49-F238E27FC236}">
+                    <a16:creationId xmlns:a16="http://schemas.microsoft.com/office/drawing/2014/main" id="{9310F2AA-E0A9-C691-E0F6-FD8806595E1B}"/>
+                  </a:ext>
+                </a:extLst>
+              </p:cNvPr>
+              <p:cNvSpPr/>
+              <p:nvPr/>
+            </p:nvSpPr>
+            <p:spPr>
+              <a:xfrm rot="10550342">
+                <a:off x="3928893" y="4250691"/>
+                <a:ext cx="2899237" cy="1932252"/>
+              </a:xfrm>
+              <a:custGeom>
+                <a:avLst/>
+                <a:gdLst>
+                  <a:gd name="csX0" fmla="*/ 2439956 w 2899237"/>
+                  <a:gd name="csY0" fmla="*/ 1932252 h 1932252"/>
+                  <a:gd name="csX1" fmla="*/ 2182161 w 2899237"/>
+                  <a:gd name="csY1" fmla="*/ 1422236 h 1932252"/>
+                  <a:gd name="csX2" fmla="*/ 2012489 w 2899237"/>
+                  <a:gd name="csY2" fmla="*/ 1162636 h 1932252"/>
+                  <a:gd name="csX3" fmla="*/ 1959650 w 2899237"/>
+                  <a:gd name="csY3" fmla="*/ 1084382 h 1932252"/>
+                  <a:gd name="csX4" fmla="*/ 1938412 w 2899237"/>
+                  <a:gd name="csY4" fmla="*/ 1087339 h 1932252"/>
+                  <a:gd name="csX5" fmla="*/ 1955248 w 2899237"/>
+                  <a:gd name="csY5" fmla="*/ 1077862 h 1932252"/>
+                  <a:gd name="csX6" fmla="*/ 1928786 w 2899237"/>
+                  <a:gd name="csY6" fmla="*/ 1038674 h 1932252"/>
+                  <a:gd name="csX7" fmla="*/ 1898987 w 2899237"/>
+                  <a:gd name="csY7" fmla="*/ 988617 h 1932252"/>
+                  <a:gd name="csX8" fmla="*/ 1889164 w 2899237"/>
+                  <a:gd name="csY8" fmla="*/ 975927 h 1932252"/>
+                  <a:gd name="csX9" fmla="*/ 290959 w 2899237"/>
+                  <a:gd name="csY9" fmla="*/ 736386 h 1932252"/>
+                  <a:gd name="csX10" fmla="*/ 0 w 2899237"/>
+                  <a:gd name="csY10" fmla="*/ 276025 h 1932252"/>
+                  <a:gd name="csX11" fmla="*/ 2216152 w 2899237"/>
+                  <a:gd name="csY11" fmla="*/ 527298 h 1932252"/>
+                  <a:gd name="csX12" fmla="*/ 2333318 w 2899237"/>
+                  <a:gd name="csY12" fmla="*/ 658264 h 1932252"/>
+                  <a:gd name="csX13" fmla="*/ 2337502 w 2899237"/>
+                  <a:gd name="csY13" fmla="*/ 655844 h 1932252"/>
+                  <a:gd name="csX14" fmla="*/ 2399987 w 2899237"/>
+                  <a:gd name="csY14" fmla="*/ 748060 h 1932252"/>
+                  <a:gd name="csX15" fmla="*/ 2412486 w 2899237"/>
+                  <a:gd name="csY15" fmla="*/ 766650 h 1932252"/>
+                  <a:gd name="csX16" fmla="*/ 2440309 w 2899237"/>
+                  <a:gd name="csY16" fmla="*/ 804814 h 1932252"/>
+                  <a:gd name="csX17" fmla="*/ 2466357 w 2899237"/>
+                  <a:gd name="csY17" fmla="*/ 790152 h 1932252"/>
+                  <a:gd name="csX18" fmla="*/ 2445706 w 2899237"/>
+                  <a:gd name="csY18" fmla="*/ 816064 h 1932252"/>
+                  <a:gd name="csX19" fmla="*/ 2479267 w 2899237"/>
+                  <a:gd name="csY19" fmla="*/ 865984 h 1932252"/>
+                  <a:gd name="csX20" fmla="*/ 2641089 w 2899237"/>
+                  <a:gd name="csY20" fmla="*/ 1124940 h 1932252"/>
+                  <a:gd name="csX21" fmla="*/ 2899237 w 2899237"/>
+                  <a:gd name="csY21" fmla="*/ 1645265 h 1932252"/>
+                </a:gdLst>
+                <a:ahLst/>
+                <a:cxnLst>
+                  <a:cxn ang="0">
+                    <a:pos x="csX0" y="csY0"/>
+                  </a:cxn>
+                  <a:cxn ang="0">
+                    <a:pos x="csX1" y="csY1"/>
+                  </a:cxn>
+                  <a:cxn ang="0">
+                    <a:pos x="csX2" y="csY2"/>
+                  </a:cxn>
+                  <a:cxn ang="0">
+                    <a:pos x="csX3" y="csY3"/>
+                  </a:cxn>
+                  <a:cxn ang="0">
+                    <a:pos x="csX4" y="csY4"/>
+                  </a:cxn>
+                  <a:cxn ang="0">
+                    <a:pos x="csX5" y="csY5"/>
+                  </a:cxn>
+                  <a:cxn ang="0">
+                    <a:pos x="csX6" y="csY6"/>
+                  </a:cxn>
+                  <a:cxn ang="0">
+                    <a:pos x="csX7" y="csY7"/>
+                  </a:cxn>
+                  <a:cxn ang="0">
+                    <a:pos x="csX8" y="csY8"/>
+                  </a:cxn>
+                  <a:cxn ang="0">
+                    <a:pos x="csX9" y="csY9"/>
+                  </a:cxn>
+                  <a:cxn ang="0">
+                    <a:pos x="csX10" y="csY10"/>
+                  </a:cxn>
+                  <a:cxn ang="0">
+                    <a:pos x="csX11" y="csY11"/>
+                  </a:cxn>
+                  <a:cxn ang="0">
+                    <a:pos x="csX12" y="csY12"/>
+                  </a:cxn>
+                  <a:cxn ang="0">
+                    <a:pos x="csX13" y="csY13"/>
+                  </a:cxn>
+                  <a:cxn ang="0">
+                    <a:pos x="csX14" y="csY14"/>
+                  </a:cxn>
+                  <a:cxn ang="0">
+                    <a:pos x="csX15" y="csY15"/>
+                  </a:cxn>
+                  <a:cxn ang="0">
+                    <a:pos x="csX16" y="csY16"/>
+                  </a:cxn>
+                  <a:cxn ang="0">
+                    <a:pos x="csX17" y="csY17"/>
+                  </a:cxn>
+                  <a:cxn ang="0">
+                    <a:pos x="csX18" y="csY18"/>
+                  </a:cxn>
+                  <a:cxn ang="0">
+                    <a:pos x="csX19" y="csY19"/>
+                  </a:cxn>
+                  <a:cxn ang="0">
+                    <a:pos x="csX20" y="csY20"/>
+                  </a:cxn>
+                  <a:cxn ang="0">
+                    <a:pos x="csX21" y="csY21"/>
+                  </a:cxn>
+                </a:cxnLst>
+                <a:rect l="l" t="t" r="r" b="b"/>
+                <a:pathLst>
+                  <a:path w="2899237" h="1932252">
+                    <a:moveTo>
+                      <a:pt x="2439956" y="1932252"/>
+                    </a:moveTo>
+                    <a:cubicBezTo>
+                      <a:pt x="2371515" y="1817205"/>
+                      <a:pt x="2278160" y="1589314"/>
+                      <a:pt x="2182161" y="1422236"/>
+                    </a:cubicBezTo>
+                    <a:cubicBezTo>
+                      <a:pt x="2134162" y="1338697"/>
+                      <a:pt x="2071563" y="1248437"/>
+                      <a:pt x="2012489" y="1162636"/>
+                    </a:cubicBezTo>
+                    <a:lnTo>
+                      <a:pt x="1959650" y="1084382"/>
+                    </a:lnTo>
+                    <a:lnTo>
+                      <a:pt x="1938412" y="1087339"/>
+                    </a:lnTo>
+                    <a:lnTo>
+                      <a:pt x="1955248" y="1077862"/>
+                    </a:lnTo>
+                    <a:lnTo>
+                      <a:pt x="1928786" y="1038674"/>
+                    </a:lnTo>
+                    <a:lnTo>
+                      <a:pt x="1898987" y="988617"/>
+                    </a:lnTo>
+                    <a:lnTo>
+                      <a:pt x="1889164" y="975927"/>
+                    </a:lnTo>
+                    <a:cubicBezTo>
+                      <a:pt x="1494405" y="514697"/>
+                      <a:pt x="814058" y="405168"/>
+                      <a:pt x="290959" y="736386"/>
+                    </a:cubicBezTo>
+                    <a:lnTo>
+                      <a:pt x="0" y="276025"/>
+                    </a:lnTo>
+                    <a:cubicBezTo>
+                      <a:pt x="718661" y="-178765"/>
+                      <a:pt x="1640059" y="-55422"/>
+                      <a:pt x="2216152" y="527298"/>
+                    </a:cubicBezTo>
+                    <a:lnTo>
+                      <a:pt x="2333318" y="658264"/>
+                    </a:lnTo>
+                    <a:lnTo>
+                      <a:pt x="2337502" y="655844"/>
+                    </a:lnTo>
+                    <a:cubicBezTo>
+                      <a:pt x="2354222" y="680798"/>
+                      <a:pt x="2375706" y="712286"/>
+                      <a:pt x="2399987" y="748060"/>
+                    </a:cubicBezTo>
+                    <a:lnTo>
+                      <a:pt x="2412486" y="766650"/>
+                    </a:lnTo>
+                    <a:lnTo>
+                      <a:pt x="2440309" y="804814"/>
+                    </a:lnTo>
+                    <a:lnTo>
+                      <a:pt x="2466357" y="790152"/>
+                    </a:lnTo>
+                    <a:lnTo>
+                      <a:pt x="2445706" y="816064"/>
+                    </a:lnTo>
+                    <a:lnTo>
+                      <a:pt x="2479267" y="865984"/>
+                    </a:lnTo>
+                    <a:cubicBezTo>
+                      <a:pt x="2535101" y="950168"/>
+                      <a:pt x="2594277" y="1042489"/>
+                      <a:pt x="2641089" y="1124940"/>
+                    </a:cubicBezTo>
+                    <a:cubicBezTo>
+                      <a:pt x="2727198" y="1298168"/>
+                      <a:pt x="2823134" y="1516765"/>
+                      <a:pt x="2899237" y="1645265"/>
+                    </a:cubicBezTo>
+                    <a:close/>
+                  </a:path>
+                </a:pathLst>
+              </a:custGeom>
+              <a:solidFill>
+                <a:srgbClr val="893625"/>
+              </a:solidFill>
+              <a:ln>
+                <a:solidFill>
+                  <a:schemeClr val="bg1"/>
+                </a:solidFill>
+              </a:ln>
+            </p:spPr>
+            <p:style>
+              <a:lnRef idx="0">
+                <a:scrgbClr r="0" g="0" b="0"/>
+              </a:lnRef>
+              <a:fillRef idx="0">
+                <a:scrgbClr r="0" g="0" b="0"/>
+              </a:fillRef>
+              <a:effectRef idx="0">
+                <a:scrgbClr r="0" g="0" b="0"/>
+              </a:effectRef>
+              <a:fontRef idx="minor">
+                <a:schemeClr val="lt1"/>
+              </a:fontRef>
+            </p:style>
+            <p:txBody>
+              <a:bodyPr wrap="square" rtlCol="0" anchor="ctr">
+                <a:noAutofit/>
+              </a:bodyPr>
+              <a:lstStyle/>
+              <a:p>
+                <a:pPr marL="0" marR="0" lvl="0" indent="0" algn="ctr" defTabSz="914400" rtl="0" eaLnBrk="1" fontAlgn="auto" latinLnBrk="0" hangingPunct="1">
+                  <a:lnSpc>
+                    <a:spcPct val="95000"/>
+                  </a:lnSpc>
+                  <a:spcBef>
+                    <a:spcPts val="0"/>
+                  </a:spcBef>
+                  <a:spcAft>
+                    <a:spcPts val="0"/>
+                  </a:spcAft>
+                  <a:buClrTx/>
+                  <a:buSzTx/>
+                  <a:buFontTx/>
+                  <a:buNone/>
+                  <a:tabLst/>
+                  <a:defRPr/>
+                </a:pPr>
+                <a:endParaRPr kumimoji="0" lang="en-US" sz="1800" b="1" i="0" u="none" strike="noStrike" kern="1200" cap="none" spc="0" normalizeH="0" baseline="0" noProof="0">
+                  <a:ln>
+                    <a:noFill/>
+                  </a:ln>
+                  <a:solidFill>
+                    <a:srgbClr val="C9BC9B"/>
+                  </a:solidFill>
+                  <a:effectLst/>
+                  <a:uLnTx/>
+                  <a:uFillTx/>
+                  <a:latin typeface="Source Sans Pro" panose="020B0503030403020204" pitchFamily="34" charset="0"/>
+                  <a:ea typeface="Source Sans Pro" panose="020B0503030403020204" pitchFamily="34" charset="0"/>
+                </a:endParaRPr>
+              </a:p>
+            </p:txBody>
+          </p:sp>
+          <p:sp>
+            <p:nvSpPr>
+              <p:cNvPr id="12" name="Circular Arrow 11">
+                <a:extLst>
+                  <a:ext uri="{FF2B5EF4-FFF2-40B4-BE49-F238E27FC236}">
+                    <a16:creationId xmlns:a16="http://schemas.microsoft.com/office/drawing/2014/main" id="{B13E1B77-DF48-98B1-B958-B52C4DE30631}"/>
+                  </a:ext>
+                </a:extLst>
+              </p:cNvPr>
+              <p:cNvSpPr/>
+              <p:nvPr/>
+            </p:nvSpPr>
+            <p:spPr>
+              <a:xfrm rot="6227262">
+                <a:off x="4005234" y="2555374"/>
+                <a:ext cx="3621730" cy="3623994"/>
+              </a:xfrm>
+              <a:prstGeom prst="circularArrow">
+                <a:avLst>
+                  <a:gd name="adj1" fmla="val 15037"/>
+                  <a:gd name="adj2" fmla="val 1142319"/>
+                  <a:gd name="adj3" fmla="val 19561631"/>
+                  <a:gd name="adj4" fmla="val 12438665"/>
+                  <a:gd name="adj5" fmla="val 8364"/>
+                </a:avLst>
+              </a:prstGeom>
+              <a:solidFill>
+                <a:srgbClr val="A44E3C"/>
+              </a:solidFill>
+              <a:ln w="19050">
+                <a:solidFill>
+                  <a:schemeClr val="bg1"/>
+                </a:solidFill>
+              </a:ln>
+            </p:spPr>
+            <p:style>
+              <a:lnRef idx="0">
+                <a:scrgbClr r="0" g="0" b="0"/>
+              </a:lnRef>
+              <a:fillRef idx="0">
+                <a:scrgbClr r="0" g="0" b="0"/>
+              </a:fillRef>
+              <a:effectRef idx="0">
+                <a:scrgbClr r="0" g="0" b="0"/>
+              </a:effectRef>
+              <a:fontRef idx="minor">
+                <a:schemeClr val="lt1"/>
+              </a:fontRef>
+            </p:style>
+            <p:txBody>
+              <a:bodyPr rtlCol="0" anchor="ctr"/>
+              <a:lstStyle/>
+              <a:p>
+                <a:pPr marL="0" marR="0" lvl="0" indent="0" algn="ctr" defTabSz="914400" rtl="0" eaLnBrk="1" fontAlgn="auto" latinLnBrk="0" hangingPunct="1">
+                  <a:lnSpc>
+                    <a:spcPct val="95000"/>
+                  </a:lnSpc>
+                  <a:spcBef>
+                    <a:spcPts val="0"/>
+                  </a:spcBef>
+                  <a:spcAft>
+                    <a:spcPts val="0"/>
+                  </a:spcAft>
+                  <a:buClrTx/>
+                  <a:buSzTx/>
+                  <a:buFontTx/>
+                  <a:buNone/>
+                  <a:tabLst/>
+                  <a:defRPr/>
+                </a:pPr>
+                <a:endParaRPr kumimoji="0" lang="en-US" sz="1800" b="1" i="0" u="none" strike="noStrike" kern="1200" cap="none" spc="0" normalizeH="0" baseline="0" noProof="0">
+                  <a:ln>
+                    <a:noFill/>
+                  </a:ln>
+                  <a:solidFill>
+                    <a:srgbClr val="C9BC9B"/>
+                  </a:solidFill>
+                  <a:effectLst/>
+                  <a:uLnTx/>
+                  <a:uFillTx/>
+                  <a:latin typeface="Source Sans Pro" panose="020B0503030403020204" pitchFamily="34" charset="0"/>
+                  <a:ea typeface="Source Sans Pro" panose="020B0503030403020204" pitchFamily="34" charset="0"/>
+                </a:endParaRPr>
+              </a:p>
+            </p:txBody>
+          </p:sp>
+          <p:sp>
+            <p:nvSpPr>
+              <p:cNvPr id="13" name="Freeform 12">
+                <a:extLst>
+                  <a:ext uri="{FF2B5EF4-FFF2-40B4-BE49-F238E27FC236}">
+                    <a16:creationId xmlns:a16="http://schemas.microsoft.com/office/drawing/2014/main" id="{6BAFEE5A-A585-65FD-E7D8-6D7FF98FABB6}"/>
+                  </a:ext>
+                </a:extLst>
+              </p:cNvPr>
+              <p:cNvSpPr/>
+              <p:nvPr/>
+            </p:nvSpPr>
+            <p:spPr>
+              <a:xfrm rot="7442250" flipH="1">
+                <a:off x="3883085" y="2671932"/>
+                <a:ext cx="3228928" cy="2558989"/>
+              </a:xfrm>
+              <a:custGeom>
+                <a:avLst/>
+                <a:gdLst>
+                  <a:gd name="csX0" fmla="*/ 2915225 w 3228928"/>
+                  <a:gd name="csY0" fmla="*/ 1792995 h 2558989"/>
+                  <a:gd name="csX1" fmla="*/ 3166129 w 3228928"/>
+                  <a:gd name="csY1" fmla="*/ 315091 h 2558989"/>
+                  <a:gd name="csX2" fmla="*/ 3181085 w 3228928"/>
+                  <a:gd name="csY2" fmla="*/ 306009 h 2558989"/>
+                  <a:gd name="csX3" fmla="*/ 2737077 w 3228928"/>
+                  <a:gd name="csY3" fmla="*/ 0 h 2558989"/>
+                  <a:gd name="csX4" fmla="*/ 2663236 w 3228928"/>
+                  <a:gd name="csY4" fmla="*/ 620457 h 2558989"/>
+                  <a:gd name="csX5" fmla="*/ 2672696 w 3228928"/>
+                  <a:gd name="csY5" fmla="*/ 614712 h 2558989"/>
+                  <a:gd name="csX6" fmla="*/ 2419214 w 3228928"/>
+                  <a:gd name="csY6" fmla="*/ 1548532 h 2558989"/>
+                  <a:gd name="csX7" fmla="*/ 1694218 w 3228928"/>
+                  <a:gd name="csY7" fmla="*/ 1994367 h 2558989"/>
+                  <a:gd name="csX8" fmla="*/ 1652435 w 3228928"/>
+                  <a:gd name="csY8" fmla="*/ 2000629 h 2558989"/>
+                  <a:gd name="csX9" fmla="*/ 1572718 w 3228928"/>
+                  <a:gd name="csY9" fmla="*/ 1998011 h 2558989"/>
+                  <a:gd name="csX10" fmla="*/ 816852 w 3228928"/>
+                  <a:gd name="csY10" fmla="*/ 2009712 h 2558989"/>
+                  <a:gd name="csX11" fmla="*/ 0 w 3228928"/>
+                  <a:gd name="csY11" fmla="*/ 1958070 h 2558989"/>
+                  <a:gd name="csX12" fmla="*/ 0 w 3228928"/>
+                  <a:gd name="csY12" fmla="*/ 2499643 h 2558989"/>
+                  <a:gd name="csX13" fmla="*/ 829668 w 3228928"/>
+                  <a:gd name="csY13" fmla="*/ 2556447 h 2558989"/>
+                  <a:gd name="csX14" fmla="*/ 1558753 w 3228928"/>
+                  <a:gd name="csY14" fmla="*/ 2549379 h 2558989"/>
+                  <a:gd name="csX15" fmla="*/ 1623347 w 3228928"/>
+                  <a:gd name="csY15" fmla="*/ 2547774 h 2558989"/>
+                  <a:gd name="csX16" fmla="*/ 1624053 w 3228928"/>
+                  <a:gd name="csY16" fmla="*/ 2554883 h 2558989"/>
+                  <a:gd name="csX17" fmla="*/ 2915225 w 3228928"/>
+                  <a:gd name="csY17" fmla="*/ 1792995 h 2558989"/>
+                </a:gdLst>
+                <a:ahLst/>
+                <a:cxnLst>
+                  <a:cxn ang="0">
+                    <a:pos x="csX0" y="csY0"/>
+                  </a:cxn>
+                  <a:cxn ang="0">
+                    <a:pos x="csX1" y="csY1"/>
+                  </a:cxn>
+                  <a:cxn ang="0">
+                    <a:pos x="csX2" y="csY2"/>
+                  </a:cxn>
+                  <a:cxn ang="0">
+                    <a:pos x="csX3" y="csY3"/>
+                  </a:cxn>
+                  <a:cxn ang="0">
+                    <a:pos x="csX4" y="csY4"/>
+                  </a:cxn>
+                  <a:cxn ang="0">
+                    <a:pos x="csX5" y="csY5"/>
+                  </a:cxn>
+                  <a:cxn ang="0">
+                    <a:pos x="csX6" y="csY6"/>
+                  </a:cxn>
+                  <a:cxn ang="0">
+                    <a:pos x="csX7" y="csY7"/>
+                  </a:cxn>
+                  <a:cxn ang="0">
+                    <a:pos x="csX8" y="csY8"/>
+                  </a:cxn>
+                  <a:cxn ang="0">
+                    <a:pos x="csX9" y="csY9"/>
+                  </a:cxn>
+                  <a:cxn ang="0">
+                    <a:pos x="csX10" y="csY10"/>
+                  </a:cxn>
+                  <a:cxn ang="0">
+                    <a:pos x="csX11" y="csY11"/>
+                  </a:cxn>
+                  <a:cxn ang="0">
+                    <a:pos x="csX12" y="csY12"/>
+                  </a:cxn>
+                  <a:cxn ang="0">
+                    <a:pos x="csX13" y="csY13"/>
+                  </a:cxn>
+                  <a:cxn ang="0">
+                    <a:pos x="csX14" y="csY14"/>
+                  </a:cxn>
+                  <a:cxn ang="0">
+                    <a:pos x="csX15" y="csY15"/>
+                  </a:cxn>
+                  <a:cxn ang="0">
+                    <a:pos x="csX16" y="csY16"/>
+                  </a:cxn>
+                  <a:cxn ang="0">
+                    <a:pos x="csX17" y="csY17"/>
+                  </a:cxn>
+                </a:cxnLst>
+                <a:rect l="l" t="t" r="r" b="b"/>
+                <a:pathLst>
+                  <a:path w="3228928" h="2558989">
+                    <a:moveTo>
+                      <a:pt x="2915225" y="1792995"/>
+                    </a:moveTo>
+                    <a:cubicBezTo>
+                      <a:pt x="3212287" y="1361418"/>
+                      <a:pt x="3304070" y="820782"/>
+                      <a:pt x="3166129" y="315091"/>
+                    </a:cubicBezTo>
+                    <a:lnTo>
+                      <a:pt x="3181085" y="306009"/>
+                    </a:lnTo>
+                    <a:lnTo>
+                      <a:pt x="2737077" y="0"/>
+                    </a:lnTo>
+                    <a:lnTo>
+                      <a:pt x="2663236" y="620457"/>
+                    </a:lnTo>
+                    <a:lnTo>
+                      <a:pt x="2672696" y="614712"/>
+                    </a:lnTo>
+                    <a:cubicBezTo>
+                      <a:pt x="2718664" y="947614"/>
+                      <a:pt x="2627148" y="1284761"/>
+                      <a:pt x="2419214" y="1548532"/>
+                    </a:cubicBezTo>
+                    <a:cubicBezTo>
+                      <a:pt x="2237229" y="1779386"/>
+                      <a:pt x="1979798" y="1936622"/>
+                      <a:pt x="1694218" y="1994367"/>
+                    </a:cubicBezTo>
+                    <a:lnTo>
+                      <a:pt x="1652435" y="2000629"/>
+                    </a:lnTo>
+                    <a:lnTo>
+                      <a:pt x="1572718" y="1998011"/>
+                    </a:lnTo>
+                    <a:cubicBezTo>
+                      <a:pt x="1359568" y="1995172"/>
+                      <a:pt x="1058683" y="2015946"/>
+                      <a:pt x="816852" y="2009712"/>
+                    </a:cubicBezTo>
+                    <a:cubicBezTo>
+                      <a:pt x="540474" y="2002587"/>
+                      <a:pt x="192087" y="1960994"/>
+                      <a:pt x="0" y="1958070"/>
+                    </a:cubicBezTo>
+                    <a:lnTo>
+                      <a:pt x="0" y="2499643"/>
+                    </a:lnTo>
+                    <a:cubicBezTo>
+                      <a:pt x="214289" y="2503198"/>
+                      <a:pt x="553327" y="2537677"/>
+                      <a:pt x="829668" y="2556447"/>
+                    </a:cubicBezTo>
+                    <a:cubicBezTo>
+                      <a:pt x="1067602" y="2563436"/>
+                      <a:pt x="1371122" y="2554328"/>
+                      <a:pt x="1558753" y="2549379"/>
+                    </a:cubicBezTo>
+                    <a:lnTo>
+                      <a:pt x="1623347" y="2547774"/>
+                    </a:lnTo>
+                    <a:lnTo>
+                      <a:pt x="1624053" y="2554883"/>
+                    </a:lnTo>
+                    <a:cubicBezTo>
+                      <a:pt x="2145730" y="2503415"/>
+                      <a:pt x="2618081" y="2224692"/>
+                      <a:pt x="2915225" y="1792995"/>
+                    </a:cubicBezTo>
+                    <a:close/>
+                  </a:path>
+                </a:pathLst>
+              </a:custGeom>
+              <a:solidFill>
+                <a:srgbClr val="C36957"/>
+              </a:solidFill>
+              <a:ln w="19050">
+                <a:solidFill>
+                  <a:schemeClr val="bg1"/>
+                </a:solidFill>
+              </a:ln>
+            </p:spPr>
+            <p:style>
+              <a:lnRef idx="0">
+                <a:scrgbClr r="0" g="0" b="0"/>
+              </a:lnRef>
+              <a:fillRef idx="0">
+                <a:scrgbClr r="0" g="0" b="0"/>
+              </a:fillRef>
+              <a:effectRef idx="0">
+                <a:scrgbClr r="0" g="0" b="0"/>
+              </a:effectRef>
+              <a:fontRef idx="minor">
+                <a:schemeClr val="lt1"/>
+              </a:fontRef>
+            </p:style>
+            <p:txBody>
+              <a:bodyPr wrap="square" rtlCol="0" anchor="ctr">
+                <a:noAutofit/>
+              </a:bodyPr>
+              <a:lstStyle/>
+              <a:p>
+                <a:pPr marL="0" marR="0" lvl="0" indent="0" algn="ctr" defTabSz="914400" rtl="0" eaLnBrk="1" fontAlgn="auto" latinLnBrk="0" hangingPunct="1">
+                  <a:lnSpc>
+                    <a:spcPct val="95000"/>
+                  </a:lnSpc>
+                  <a:spcBef>
+                    <a:spcPts val="0"/>
+                  </a:spcBef>
+                  <a:spcAft>
+                    <a:spcPts val="0"/>
+                  </a:spcAft>
+                  <a:buClrTx/>
+                  <a:buSzTx/>
+                  <a:buFontTx/>
+                  <a:buNone/>
+                  <a:tabLst/>
+                  <a:defRPr/>
+                </a:pPr>
+                <a:endParaRPr kumimoji="0" lang="en-US" sz="1800" b="1" i="0" u="none" strike="noStrike" kern="1200" cap="none" spc="0" normalizeH="0" baseline="0" noProof="0">
+                  <a:ln>
+                    <a:noFill/>
+                  </a:ln>
+                  <a:solidFill>
+                    <a:srgbClr val="C9BC9B"/>
+                  </a:solidFill>
+                  <a:effectLst/>
+                  <a:uLnTx/>
+                  <a:uFillTx/>
+                  <a:latin typeface="Source Sans Pro" panose="020B0503030403020204" pitchFamily="34" charset="0"/>
+                  <a:ea typeface="Source Sans Pro" panose="020B0503030403020204" pitchFamily="34" charset="0"/>
+                </a:endParaRPr>
+              </a:p>
+            </p:txBody>
+          </p:sp>
+          <p:sp>
+            <p:nvSpPr>
+              <p:cNvPr id="14" name="Freeform 13">
+                <a:extLst>
+                  <a:ext uri="{FF2B5EF4-FFF2-40B4-BE49-F238E27FC236}">
+                    <a16:creationId xmlns:a16="http://schemas.microsoft.com/office/drawing/2014/main" id="{3E7350CE-1A43-6555-8C02-28CFC3015674}"/>
+                  </a:ext>
+                </a:extLst>
+              </p:cNvPr>
+              <p:cNvSpPr/>
+              <p:nvPr/>
+            </p:nvSpPr>
+            <p:spPr>
+              <a:xfrm rot="18258322">
+                <a:off x="1327855" y="4205243"/>
+                <a:ext cx="2873253" cy="1874628"/>
+              </a:xfrm>
+              <a:custGeom>
+                <a:avLst/>
+                <a:gdLst>
+                  <a:gd name="csX0" fmla="*/ 2873253 w 2873253"/>
+                  <a:gd name="csY0" fmla="*/ 1567425 h 1874628"/>
+                  <a:gd name="csX1" fmla="*/ 2602467 w 2873253"/>
+                  <a:gd name="csY1" fmla="*/ 1838211 h 1874628"/>
+                  <a:gd name="csX2" fmla="*/ 1698669 w 2873253"/>
+                  <a:gd name="csY2" fmla="*/ 1838211 h 1874628"/>
+                  <a:gd name="csX3" fmla="*/ 1684470 w 2873253"/>
+                  <a:gd name="csY3" fmla="*/ 1874628 h 1874628"/>
+                  <a:gd name="csX4" fmla="*/ 1684068 w 2873253"/>
+                  <a:gd name="csY4" fmla="*/ 1844740 h 1874628"/>
+                  <a:gd name="csX5" fmla="*/ 1621419 w 2873253"/>
+                  <a:gd name="csY5" fmla="*/ 1838211 h 1874628"/>
+                  <a:gd name="csX6" fmla="*/ 1618364 w 2873253"/>
+                  <a:gd name="csY6" fmla="*/ 1838211 h 1874628"/>
+                  <a:gd name="csX7" fmla="*/ 1618364 w 2873253"/>
+                  <a:gd name="csY7" fmla="*/ 1837893 h 1874628"/>
+                  <a:gd name="csX8" fmla="*/ 1504778 w 2873253"/>
+                  <a:gd name="csY8" fmla="*/ 1826055 h 1874628"/>
+                  <a:gd name="csX9" fmla="*/ 1314 w 2873253"/>
+                  <a:gd name="csY9" fmla="*/ 0 h 1874628"/>
+                  <a:gd name="csX10" fmla="*/ 545531 w 2873253"/>
+                  <a:gd name="csY10" fmla="*/ 20426 h 1874628"/>
+                  <a:gd name="csX11" fmla="*/ 1555265 w 2873253"/>
+                  <a:gd name="csY11" fmla="*/ 1282201 h 1874628"/>
+                  <a:gd name="csX12" fmla="*/ 1663502 w 2873253"/>
+                  <a:gd name="csY12" fmla="*/ 1296638 h 1874628"/>
+                  <a:gd name="csX13" fmla="*/ 1676715 w 2873253"/>
+                  <a:gd name="csY13" fmla="*/ 1296638 h 1874628"/>
+                  <a:gd name="csX14" fmla="*/ 1676342 w 2873253"/>
+                  <a:gd name="csY14" fmla="*/ 1268840 h 1874628"/>
+                  <a:gd name="csX15" fmla="*/ 1687696 w 2873253"/>
+                  <a:gd name="csY15" fmla="*/ 1296638 h 1874628"/>
+                  <a:gd name="csX16" fmla="*/ 2602467 w 2873253"/>
+                  <a:gd name="csY16" fmla="*/ 1296638 h 1874628"/>
+                </a:gdLst>
+                <a:ahLst/>
+                <a:cxnLst>
+                  <a:cxn ang="0">
+                    <a:pos x="csX0" y="csY0"/>
+                  </a:cxn>
+                  <a:cxn ang="0">
+                    <a:pos x="csX1" y="csY1"/>
+                  </a:cxn>
+                  <a:cxn ang="0">
+                    <a:pos x="csX2" y="csY2"/>
+                  </a:cxn>
+                  <a:cxn ang="0">
+                    <a:pos x="csX3" y="csY3"/>
+                  </a:cxn>
+                  <a:cxn ang="0">
+                    <a:pos x="csX4" y="csY4"/>
+                  </a:cxn>
+                  <a:cxn ang="0">
+                    <a:pos x="csX5" y="csY5"/>
+                  </a:cxn>
+                  <a:cxn ang="0">
+                    <a:pos x="csX6" y="csY6"/>
+                  </a:cxn>
+                  <a:cxn ang="0">
+                    <a:pos x="csX7" y="csY7"/>
+                  </a:cxn>
+                  <a:cxn ang="0">
+                    <a:pos x="csX8" y="csY8"/>
+                  </a:cxn>
+                  <a:cxn ang="0">
+                    <a:pos x="csX9" y="csY9"/>
+                  </a:cxn>
+                  <a:cxn ang="0">
+                    <a:pos x="csX10" y="csY10"/>
+                  </a:cxn>
+                  <a:cxn ang="0">
+                    <a:pos x="csX11" y="csY11"/>
+                  </a:cxn>
+                  <a:cxn ang="0">
+                    <a:pos x="csX12" y="csY12"/>
+                  </a:cxn>
+                  <a:cxn ang="0">
+                    <a:pos x="csX13" y="csY13"/>
+                  </a:cxn>
+                  <a:cxn ang="0">
+                    <a:pos x="csX14" y="csY14"/>
+                  </a:cxn>
+                  <a:cxn ang="0">
+                    <a:pos x="csX15" y="csY15"/>
+                  </a:cxn>
+                  <a:cxn ang="0">
+                    <a:pos x="csX16" y="csY16"/>
+                  </a:cxn>
+                </a:cxnLst>
+                <a:rect l="l" t="t" r="r" b="b"/>
+                <a:pathLst>
+                  <a:path w="2873253" h="1874628">
+                    <a:moveTo>
+                      <a:pt x="2873253" y="1567425"/>
+                    </a:moveTo>
+                    <a:lnTo>
+                      <a:pt x="2602467" y="1838211"/>
+                    </a:lnTo>
+                    <a:lnTo>
+                      <a:pt x="1698669" y="1838211"/>
+                    </a:lnTo>
+                    <a:lnTo>
+                      <a:pt x="1684470" y="1874628"/>
+                    </a:lnTo>
+                    <a:lnTo>
+                      <a:pt x="1684068" y="1844740"/>
+                    </a:lnTo>
+                    <a:lnTo>
+                      <a:pt x="1621419" y="1838211"/>
+                    </a:lnTo>
+                    <a:lnTo>
+                      <a:pt x="1618364" y="1838211"/>
+                    </a:lnTo>
+                    <a:lnTo>
+                      <a:pt x="1618364" y="1837893"/>
+                    </a:lnTo>
+                    <a:lnTo>
+                      <a:pt x="1504778" y="1826055"/>
+                    </a:lnTo>
+                    <a:cubicBezTo>
+                      <a:pt x="622706" y="1689100"/>
+                      <a:pt x="-33386" y="910562"/>
+                      <a:pt x="1314" y="0"/>
+                    </a:cubicBezTo>
+                    <a:lnTo>
+                      <a:pt x="545531" y="20426"/>
+                    </a:lnTo>
+                    <a:cubicBezTo>
+                      <a:pt x="521797" y="639113"/>
+                      <a:pt x="958170" y="1172449"/>
+                      <a:pt x="1555265" y="1282201"/>
+                    </a:cubicBezTo>
+                    <a:lnTo>
+                      <a:pt x="1663502" y="1296638"/>
+                    </a:lnTo>
+                    <a:lnTo>
+                      <a:pt x="1676715" y="1296638"/>
+                    </a:lnTo>
+                    <a:lnTo>
+                      <a:pt x="1676342" y="1268840"/>
+                    </a:lnTo>
+                    <a:lnTo>
+                      <a:pt x="1687696" y="1296638"/>
+                    </a:lnTo>
+                    <a:lnTo>
+                      <a:pt x="2602467" y="1296638"/>
+                    </a:lnTo>
+                    <a:close/>
+                  </a:path>
+                </a:pathLst>
+              </a:custGeom>
+              <a:solidFill>
+                <a:schemeClr val="accent1"/>
+              </a:solidFill>
+              <a:ln w="19050">
+                <a:solidFill>
+                  <a:schemeClr val="bg1"/>
+                </a:solidFill>
+              </a:ln>
+            </p:spPr>
+            <p:style>
+              <a:lnRef idx="0">
+                <a:scrgbClr r="0" g="0" b="0"/>
+              </a:lnRef>
+              <a:fillRef idx="0">
+                <a:scrgbClr r="0" g="0" b="0"/>
+              </a:fillRef>
+              <a:effectRef idx="0">
+                <a:scrgbClr r="0" g="0" b="0"/>
+              </a:effectRef>
+              <a:fontRef idx="minor">
+                <a:schemeClr val="lt1"/>
+              </a:fontRef>
+            </p:style>
+            <p:txBody>
+              <a:bodyPr wrap="square" rtlCol="0" anchor="ctr">
+                <a:noAutofit/>
+              </a:bodyPr>
+              <a:lstStyle/>
+              <a:p>
+                <a:pPr marL="0" marR="0" lvl="0" indent="0" algn="ctr" defTabSz="914400" rtl="0" eaLnBrk="1" fontAlgn="auto" latinLnBrk="0" hangingPunct="1">
+                  <a:lnSpc>
+                    <a:spcPct val="95000"/>
+                  </a:lnSpc>
+                  <a:spcBef>
+                    <a:spcPts val="0"/>
+                  </a:spcBef>
+                  <a:spcAft>
+                    <a:spcPts val="0"/>
+                  </a:spcAft>
+                  <a:buClrTx/>
+                  <a:buSzTx/>
+                  <a:buFontTx/>
+                  <a:buNone/>
+                  <a:tabLst/>
+                  <a:defRPr/>
+                </a:pPr>
+                <a:endParaRPr kumimoji="0" lang="en-US" sz="1800" b="1" i="0" u="none" strike="noStrike" kern="1200" cap="none" spc="0" normalizeH="0" baseline="0" noProof="0">
+                  <a:ln>
+                    <a:noFill/>
+                  </a:ln>
+                  <a:solidFill>
+                    <a:srgbClr val="C9BC9B"/>
+                  </a:solidFill>
+                  <a:effectLst/>
+                  <a:uLnTx/>
+                  <a:uFillTx/>
+                  <a:latin typeface="Source Sans Pro" panose="020B0503030403020204" pitchFamily="34" charset="0"/>
+                  <a:ea typeface="Source Sans Pro" panose="020B0503030403020204" pitchFamily="34" charset="0"/>
+                </a:endParaRPr>
+              </a:p>
+            </p:txBody>
+          </p:sp>
+          <p:sp>
+            <p:nvSpPr>
+              <p:cNvPr id="15" name="Circular Arrow 14">
+                <a:extLst>
+                  <a:ext uri="{FF2B5EF4-FFF2-40B4-BE49-F238E27FC236}">
+                    <a16:creationId xmlns:a16="http://schemas.microsoft.com/office/drawing/2014/main" id="{69C28DB2-A0E1-E998-562F-7C0658120DF0}"/>
+                  </a:ext>
+                </a:extLst>
+              </p:cNvPr>
+              <p:cNvSpPr/>
+              <p:nvPr/>
+            </p:nvSpPr>
+            <p:spPr>
+              <a:xfrm rot="15372738" flipH="1">
+                <a:off x="445623" y="2555375"/>
+                <a:ext cx="3621730" cy="3623994"/>
+              </a:xfrm>
+              <a:prstGeom prst="circularArrow">
+                <a:avLst>
+                  <a:gd name="adj1" fmla="val 15037"/>
+                  <a:gd name="adj2" fmla="val 1142319"/>
+                  <a:gd name="adj3" fmla="val 19561631"/>
+                  <a:gd name="adj4" fmla="val 12438665"/>
+                  <a:gd name="adj5" fmla="val 8364"/>
+                </a:avLst>
+              </a:prstGeom>
+              <a:solidFill>
+                <a:srgbClr val="3E6D6F"/>
+              </a:solidFill>
+              <a:ln w="19050">
+                <a:solidFill>
+                  <a:schemeClr val="bg1"/>
+                </a:solidFill>
+              </a:ln>
+            </p:spPr>
+            <p:style>
+              <a:lnRef idx="0">
+                <a:scrgbClr r="0" g="0" b="0"/>
+              </a:lnRef>
+              <a:fillRef idx="0">
+                <a:scrgbClr r="0" g="0" b="0"/>
+              </a:fillRef>
+              <a:effectRef idx="0">
+                <a:scrgbClr r="0" g="0" b="0"/>
+              </a:effectRef>
+              <a:fontRef idx="minor">
+                <a:schemeClr val="lt1"/>
+              </a:fontRef>
+            </p:style>
+            <p:txBody>
+              <a:bodyPr rtlCol="0" anchor="ctr"/>
+              <a:lstStyle/>
+              <a:p>
+                <a:pPr marL="0" marR="0" lvl="0" indent="0" algn="ctr" defTabSz="914400" rtl="0" eaLnBrk="1" fontAlgn="auto" latinLnBrk="0" hangingPunct="1">
+                  <a:lnSpc>
+                    <a:spcPct val="95000"/>
+                  </a:lnSpc>
+                  <a:spcBef>
+                    <a:spcPts val="0"/>
+                  </a:spcBef>
+                  <a:spcAft>
+                    <a:spcPts val="0"/>
+                  </a:spcAft>
+                  <a:buClrTx/>
+                  <a:buSzTx/>
+                  <a:buFontTx/>
+                  <a:buNone/>
+                  <a:tabLst/>
+                  <a:defRPr/>
+                </a:pPr>
+                <a:endParaRPr kumimoji="0" lang="en-US" sz="1800" b="1" i="0" u="none" strike="noStrike" kern="1200" cap="none" spc="0" normalizeH="0" baseline="0" noProof="0">
+                  <a:ln>
+                    <a:noFill/>
+                  </a:ln>
+                  <a:solidFill>
+                    <a:srgbClr val="C9BC9B"/>
+                  </a:solidFill>
+                  <a:effectLst/>
+                  <a:uLnTx/>
+                  <a:uFillTx/>
+                  <a:latin typeface="Source Sans Pro" panose="020B0503030403020204" pitchFamily="34" charset="0"/>
+                  <a:ea typeface="Source Sans Pro" panose="020B0503030403020204" pitchFamily="34" charset="0"/>
+                </a:endParaRPr>
+              </a:p>
+            </p:txBody>
+          </p:sp>
+          <p:sp>
+            <p:nvSpPr>
+              <p:cNvPr id="16" name="Freeform 15">
+                <a:extLst>
+                  <a:ext uri="{FF2B5EF4-FFF2-40B4-BE49-F238E27FC236}">
+                    <a16:creationId xmlns:a16="http://schemas.microsoft.com/office/drawing/2014/main" id="{B2112E1D-2915-7969-C111-C01DEDE40B03}"/>
+                  </a:ext>
+                </a:extLst>
+              </p:cNvPr>
+              <p:cNvSpPr/>
+              <p:nvPr/>
+            </p:nvSpPr>
+            <p:spPr>
+              <a:xfrm rot="14157750">
+                <a:off x="1097924" y="2413413"/>
+                <a:ext cx="2617463" cy="2565616"/>
+              </a:xfrm>
+              <a:custGeom>
+                <a:avLst/>
+                <a:gdLst>
+                  <a:gd name="csX0" fmla="*/ 2303761 w 2617463"/>
+                  <a:gd name="csY0" fmla="*/ 1792995 h 2565616"/>
+                  <a:gd name="csX1" fmla="*/ 1205660 w 2617463"/>
+                  <a:gd name="csY1" fmla="*/ 2525076 h 2565616"/>
+                  <a:gd name="csX2" fmla="*/ 1023743 w 2617463"/>
+                  <a:gd name="csY2" fmla="*/ 2553162 h 2565616"/>
+                  <a:gd name="csX3" fmla="*/ 1023708 w 2617463"/>
+                  <a:gd name="csY3" fmla="*/ 2554197 h 2565616"/>
+                  <a:gd name="csX4" fmla="*/ 1015037 w 2617463"/>
+                  <a:gd name="csY4" fmla="*/ 2554506 h 2565616"/>
+                  <a:gd name="csX5" fmla="*/ 1012589 w 2617463"/>
+                  <a:gd name="csY5" fmla="*/ 2554884 h 2565616"/>
+                  <a:gd name="csX6" fmla="*/ 1012560 w 2617463"/>
+                  <a:gd name="csY6" fmla="*/ 2554594 h 2565616"/>
+                  <a:gd name="csX7" fmla="*/ 972993 w 2617463"/>
+                  <a:gd name="csY7" fmla="*/ 2556004 h 2565616"/>
+                  <a:gd name="csX8" fmla="*/ 465015 w 2617463"/>
+                  <a:gd name="csY8" fmla="*/ 2563073 h 2565616"/>
+                  <a:gd name="csX9" fmla="*/ 314463 w 2617463"/>
+                  <a:gd name="csY9" fmla="*/ 2546779 h 2565616"/>
+                  <a:gd name="csX10" fmla="*/ 278020 w 2617463"/>
+                  <a:gd name="csY10" fmla="*/ 2542582 h 2565616"/>
+                  <a:gd name="csX11" fmla="*/ 258726 w 2617463"/>
+                  <a:gd name="csY11" fmla="*/ 2496456 h 2565616"/>
+                  <a:gd name="csX12" fmla="*/ 63501 w 2617463"/>
+                  <a:gd name="csY12" fmla="*/ 2102775 h 2565616"/>
+                  <a:gd name="csX13" fmla="*/ 0 w 2617463"/>
+                  <a:gd name="csY13" fmla="*/ 1972537 h 2565616"/>
+                  <a:gd name="csX14" fmla="*/ 5265 w 2617463"/>
+                  <a:gd name="csY14" fmla="*/ 1972997 h 2565616"/>
+                  <a:gd name="csX15" fmla="*/ 456086 w 2617463"/>
+                  <a:gd name="csY15" fmla="*/ 2016338 h 2565616"/>
+                  <a:gd name="csX16" fmla="*/ 915633 w 2617463"/>
+                  <a:gd name="csY16" fmla="*/ 2004718 h 2565616"/>
+                  <a:gd name="csX17" fmla="*/ 1001371 w 2617463"/>
+                  <a:gd name="csY17" fmla="*/ 2006565 h 2565616"/>
+                  <a:gd name="csX18" fmla="*/ 1082754 w 2617463"/>
+                  <a:gd name="csY18" fmla="*/ 1994367 h 2565616"/>
+                  <a:gd name="csX19" fmla="*/ 1807749 w 2617463"/>
+                  <a:gd name="csY19" fmla="*/ 1548533 h 2565616"/>
+                  <a:gd name="csX20" fmla="*/ 2061232 w 2617463"/>
+                  <a:gd name="csY20" fmla="*/ 614713 h 2565616"/>
+                  <a:gd name="csX21" fmla="*/ 2051772 w 2617463"/>
+                  <a:gd name="csY21" fmla="*/ 620457 h 2565616"/>
+                  <a:gd name="csX22" fmla="*/ 2125612 w 2617463"/>
+                  <a:gd name="csY22" fmla="*/ 0 h 2565616"/>
+                  <a:gd name="csX23" fmla="*/ 2569621 w 2617463"/>
+                  <a:gd name="csY23" fmla="*/ 306009 h 2565616"/>
+                  <a:gd name="csX24" fmla="*/ 2554664 w 2617463"/>
+                  <a:gd name="csY24" fmla="*/ 315091 h 2565616"/>
+                  <a:gd name="csX25" fmla="*/ 2303761 w 2617463"/>
+                  <a:gd name="csY25" fmla="*/ 1792995 h 2565616"/>
+                </a:gdLst>
+                <a:ahLst/>
+                <a:cxnLst>
+                  <a:cxn ang="0">
+                    <a:pos x="csX0" y="csY0"/>
+                  </a:cxn>
+                  <a:cxn ang="0">
+                    <a:pos x="csX1" y="csY1"/>
+                  </a:cxn>
+                  <a:cxn ang="0">
+                    <a:pos x="csX2" y="csY2"/>
+                  </a:cxn>
+                  <a:cxn ang="0">
+                    <a:pos x="csX3" y="csY3"/>
+                  </a:cxn>
+                  <a:cxn ang="0">
+                    <a:pos x="csX4" y="csY4"/>
+                  </a:cxn>
+                  <a:cxn ang="0">
+                    <a:pos x="csX5" y="csY5"/>
+                  </a:cxn>
+                  <a:cxn ang="0">
+                    <a:pos x="csX6" y="csY6"/>
+                  </a:cxn>
+                  <a:cxn ang="0">
+                    <a:pos x="csX7" y="csY7"/>
+                  </a:cxn>
+                  <a:cxn ang="0">
+                    <a:pos x="csX8" y="csY8"/>
+                  </a:cxn>
+                  <a:cxn ang="0">
+                    <a:pos x="csX9" y="csY9"/>
+                  </a:cxn>
+                  <a:cxn ang="0">
+                    <a:pos x="csX10" y="csY10"/>
+                  </a:cxn>
+                  <a:cxn ang="0">
+                    <a:pos x="csX11" y="csY11"/>
+                  </a:cxn>
+                  <a:cxn ang="0">
+                    <a:pos x="csX12" y="csY12"/>
+                  </a:cxn>
+                  <a:cxn ang="0">
+                    <a:pos x="csX13" y="csY13"/>
+                  </a:cxn>
+                  <a:cxn ang="0">
+                    <a:pos x="csX14" y="csY14"/>
+                  </a:cxn>
+                  <a:cxn ang="0">
+                    <a:pos x="csX15" y="csY15"/>
+                  </a:cxn>
+                  <a:cxn ang="0">
+                    <a:pos x="csX16" y="csY16"/>
+                  </a:cxn>
+                  <a:cxn ang="0">
+                    <a:pos x="csX17" y="csY17"/>
+                  </a:cxn>
+                  <a:cxn ang="0">
+                    <a:pos x="csX18" y="csY18"/>
+                  </a:cxn>
+                  <a:cxn ang="0">
+                    <a:pos x="csX19" y="csY19"/>
+                  </a:cxn>
+                  <a:cxn ang="0">
+                    <a:pos x="csX20" y="csY20"/>
+                  </a:cxn>
+                  <a:cxn ang="0">
+                    <a:pos x="csX21" y="csY21"/>
+                  </a:cxn>
+                  <a:cxn ang="0">
+                    <a:pos x="csX22" y="csY22"/>
+                  </a:cxn>
+                  <a:cxn ang="0">
+                    <a:pos x="csX23" y="csY23"/>
+                  </a:cxn>
+                  <a:cxn ang="0">
+                    <a:pos x="csX24" y="csY24"/>
+                  </a:cxn>
+                  <a:cxn ang="0">
+                    <a:pos x="csX25" y="csY25"/>
+                  </a:cxn>
+                </a:cxnLst>
+                <a:rect l="l" t="t" r="r" b="b"/>
+                <a:pathLst>
+                  <a:path w="2617463" h="2565616">
+                    <a:moveTo>
+                      <a:pt x="2303761" y="1792995"/>
+                    </a:moveTo>
+                    <a:cubicBezTo>
+                      <a:pt x="2043759" y="2170730"/>
+                      <a:pt x="1649616" y="2431344"/>
+                      <a:pt x="1205660" y="2525076"/>
+                    </a:cubicBezTo>
+                    <a:lnTo>
+                      <a:pt x="1023743" y="2553162"/>
+                    </a:lnTo>
+                    <a:lnTo>
+                      <a:pt x="1023708" y="2554197"/>
+                    </a:lnTo>
+                    <a:lnTo>
+                      <a:pt x="1015037" y="2554506"/>
+                    </a:lnTo>
+                    <a:lnTo>
+                      <a:pt x="1012589" y="2554884"/>
+                    </a:lnTo>
+                    <a:lnTo>
+                      <a:pt x="1012560" y="2554594"/>
+                    </a:lnTo>
+                    <a:lnTo>
+                      <a:pt x="972993" y="2556004"/>
+                    </a:lnTo>
+                    <a:cubicBezTo>
+                      <a:pt x="842265" y="2560954"/>
+                      <a:pt x="630792" y="2570063"/>
+                      <a:pt x="465015" y="2563073"/>
+                    </a:cubicBezTo>
+                    <a:cubicBezTo>
+                      <a:pt x="416881" y="2558380"/>
+                      <a:pt x="366017" y="2552706"/>
+                      <a:pt x="314463" y="2546779"/>
+                    </a:cubicBezTo>
+                    <a:lnTo>
+                      <a:pt x="278020" y="2542582"/>
+                    </a:lnTo>
+                    <a:lnTo>
+                      <a:pt x="258726" y="2496456"/>
+                    </a:lnTo>
+                    <a:cubicBezTo>
+                      <a:pt x="198428" y="2371784"/>
+                      <a:pt x="128634" y="2234037"/>
+                      <a:pt x="63501" y="2102775"/>
+                    </a:cubicBezTo>
+                    <a:lnTo>
+                      <a:pt x="0" y="1972537"/>
+                    </a:lnTo>
+                    <a:lnTo>
+                      <a:pt x="5265" y="1972997"/>
+                    </a:lnTo>
+                    <a:cubicBezTo>
+                      <a:pt x="139021" y="1986262"/>
+                      <a:pt x="311664" y="2010994"/>
+                      <a:pt x="456086" y="2016338"/>
+                    </a:cubicBezTo>
+                    <a:cubicBezTo>
+                      <a:pt x="600508" y="2021682"/>
+                      <a:pt x="775158" y="2007182"/>
+                      <a:pt x="915633" y="2004718"/>
+                    </a:cubicBezTo>
+                    <a:lnTo>
+                      <a:pt x="1001371" y="2006565"/>
+                    </a:lnTo>
+                    <a:lnTo>
+                      <a:pt x="1082754" y="1994367"/>
+                    </a:lnTo>
+                    <a:cubicBezTo>
+                      <a:pt x="1368334" y="1936622"/>
+                      <a:pt x="1625765" y="1779386"/>
+                      <a:pt x="1807749" y="1548533"/>
+                    </a:cubicBezTo>
+                    <a:cubicBezTo>
+                      <a:pt x="2015684" y="1284762"/>
+                      <a:pt x="2107200" y="947615"/>
+                      <a:pt x="2061232" y="614713"/>
+                    </a:cubicBezTo>
+                    <a:lnTo>
+                      <a:pt x="2051772" y="620457"/>
+                    </a:lnTo>
+                    <a:lnTo>
+                      <a:pt x="2125612" y="0"/>
+                    </a:lnTo>
+                    <a:lnTo>
+                      <a:pt x="2569621" y="306009"/>
+                    </a:lnTo>
+                    <a:lnTo>
+                      <a:pt x="2554664" y="315091"/>
+                    </a:lnTo>
+                    <a:cubicBezTo>
+                      <a:pt x="2692606" y="820782"/>
+                      <a:pt x="2600822" y="1361418"/>
+                      <a:pt x="2303761" y="1792995"/>
+                    </a:cubicBezTo>
+                    <a:close/>
+                  </a:path>
+                </a:pathLst>
+              </a:custGeom>
+              <a:solidFill>
+                <a:srgbClr val="25565A"/>
+              </a:solidFill>
+              <a:ln w="19050">
+                <a:solidFill>
+                  <a:schemeClr val="bg1"/>
+                </a:solidFill>
+              </a:ln>
+            </p:spPr>
+            <p:style>
+              <a:lnRef idx="0">
+                <a:scrgbClr r="0" g="0" b="0"/>
+              </a:lnRef>
+              <a:fillRef idx="0">
+                <a:scrgbClr r="0" g="0" b="0"/>
+              </a:fillRef>
+              <a:effectRef idx="0">
+                <a:scrgbClr r="0" g="0" b="0"/>
+              </a:effectRef>
+              <a:fontRef idx="minor">
+                <a:schemeClr val="lt1"/>
+              </a:fontRef>
+            </p:style>
+            <p:txBody>
+              <a:bodyPr wrap="square" rtlCol="0" anchor="ctr">
+                <a:noAutofit/>
+              </a:bodyPr>
+              <a:lstStyle/>
+              <a:p>
+                <a:pPr marL="0" marR="0" lvl="0" indent="0" algn="ctr" defTabSz="914400" rtl="0" eaLnBrk="1" fontAlgn="auto" latinLnBrk="0" hangingPunct="1">
+                  <a:lnSpc>
+                    <a:spcPct val="95000"/>
+                  </a:lnSpc>
+                  <a:spcBef>
+                    <a:spcPts val="0"/>
+                  </a:spcBef>
+                  <a:spcAft>
+                    <a:spcPts val="0"/>
+                  </a:spcAft>
+                  <a:buClrTx/>
+                  <a:buSzTx/>
+                  <a:buFontTx/>
+                  <a:buNone/>
+                  <a:tabLst/>
+                  <a:defRPr/>
+                </a:pPr>
+                <a:endParaRPr kumimoji="0" lang="en-US" sz="1800" b="1" i="0" u="none" strike="noStrike" kern="1200" cap="none" spc="0" normalizeH="0" baseline="0" noProof="0">
+                  <a:ln>
+                    <a:noFill/>
+                  </a:ln>
+                  <a:solidFill>
+                    <a:srgbClr val="C9BC9B"/>
+                  </a:solidFill>
+                  <a:effectLst/>
+                  <a:uLnTx/>
+                  <a:uFillTx/>
+                  <a:latin typeface="Source Sans Pro" panose="020B0503030403020204" pitchFamily="34" charset="0"/>
+                  <a:ea typeface="Source Sans Pro" panose="020B0503030403020204" pitchFamily="34" charset="0"/>
+                </a:endParaRPr>
+              </a:p>
+            </p:txBody>
+          </p:sp>
+        </p:grpSp>
+        <p:sp>
+          <p:nvSpPr>
+            <p:cNvPr id="5" name="TextBox 4">
+              <a:extLst>
+                <a:ext uri="{FF2B5EF4-FFF2-40B4-BE49-F238E27FC236}">
+                  <a16:creationId xmlns:a16="http://schemas.microsoft.com/office/drawing/2014/main" id="{6F706CA4-29E0-C79D-86ED-B803EECEE5A4}"/>
+                </a:ext>
+              </a:extLst>
+            </p:cNvPr>
+            <p:cNvSpPr txBox="1"/>
+            <p:nvPr/>
+          </p:nvSpPr>
+          <p:spPr>
+            <a:xfrm>
+              <a:off x="1505051" y="2968779"/>
+              <a:ext cx="1453896" cy="523220"/>
+            </a:xfrm>
+            <a:prstGeom prst="rect">
+              <a:avLst/>
+            </a:prstGeom>
+            <a:noFill/>
+          </p:spPr>
+          <p:txBody>
+            <a:bodyPr wrap="none" rtlCol="0">
+              <a:prstTxWarp prst="textArchUp">
+                <a:avLst/>
+              </a:prstTxWarp>
+              <a:spAutoFit/>
+            </a:bodyPr>
+            <a:lstStyle/>
+            <a:p>
+              <a:pPr marL="0" marR="0" lvl="0" indent="0" algn="ctr" defTabSz="914400" rtl="0" eaLnBrk="1" fontAlgn="auto" latinLnBrk="0" hangingPunct="1">
+                <a:lnSpc>
+                  <a:spcPct val="100000"/>
+                </a:lnSpc>
+                <a:spcBef>
+                  <a:spcPts val="0"/>
+                </a:spcBef>
+                <a:spcAft>
+                  <a:spcPts val="0"/>
+                </a:spcAft>
+                <a:buClrTx/>
+                <a:buSzTx/>
+                <a:buFontTx/>
+                <a:buNone/>
+                <a:tabLst/>
+                <a:defRPr/>
+              </a:pPr>
+              <a:r>
+                <a:rPr kumimoji="0" lang="en-US" b="1" i="0" u="none" strike="noStrike" kern="1200" cap="none" spc="0" normalizeH="0" baseline="0" noProof="0">
+                  <a:ln>
+                    <a:noFill/>
+                  </a:ln>
+                  <a:solidFill>
+                    <a:srgbClr val="FFFFFF"/>
+                  </a:solidFill>
+                  <a:effectLst/>
+                  <a:uLnTx/>
+                  <a:uFillTx/>
+                  <a:latin typeface="Source Sans Pro" panose="020B0503030403020204" pitchFamily="34" charset="0"/>
+                  <a:ea typeface="Source Sans Pro" panose="020B0503030403020204" pitchFamily="34" charset="0"/>
+                </a:rPr>
+                <a:t>Curate</a:t>
+              </a:r>
+            </a:p>
+          </p:txBody>
+        </p:sp>
+        <p:sp>
+          <p:nvSpPr>
+            <p:cNvPr id="6" name="TextBox 5">
+              <a:extLst>
+                <a:ext uri="{FF2B5EF4-FFF2-40B4-BE49-F238E27FC236}">
+                  <a16:creationId xmlns:a16="http://schemas.microsoft.com/office/drawing/2014/main" id="{53FA8BDE-473E-E6F5-5256-7C6ABFB5A4B3}"/>
+                </a:ext>
+              </a:extLst>
+            </p:cNvPr>
+            <p:cNvSpPr txBox="1"/>
+            <p:nvPr/>
+          </p:nvSpPr>
+          <p:spPr>
+            <a:xfrm rot="19017958">
+              <a:off x="2277601" y="5092086"/>
+              <a:ext cx="1572768" cy="523220"/>
+            </a:xfrm>
+            <a:prstGeom prst="rect">
+              <a:avLst/>
+            </a:prstGeom>
+            <a:noFill/>
+          </p:spPr>
+          <p:txBody>
+            <a:bodyPr wrap="none" rtlCol="0">
+              <a:prstTxWarp prst="textArchDown">
+                <a:avLst/>
+              </a:prstTxWarp>
+              <a:spAutoFit/>
+            </a:bodyPr>
+            <a:lstStyle/>
+            <a:p>
+              <a:pPr marL="0" marR="0" lvl="0" indent="0" algn="ctr" defTabSz="914400" rtl="0" eaLnBrk="1" fontAlgn="auto" latinLnBrk="0" hangingPunct="1">
+                <a:lnSpc>
+                  <a:spcPct val="100000"/>
+                </a:lnSpc>
+                <a:spcBef>
+                  <a:spcPts val="0"/>
+                </a:spcBef>
+                <a:spcAft>
+                  <a:spcPts val="0"/>
+                </a:spcAft>
+                <a:buClrTx/>
+                <a:buSzTx/>
+                <a:buFontTx/>
+                <a:buNone/>
+                <a:tabLst/>
+                <a:defRPr/>
+              </a:pPr>
+              <a:r>
+                <a:rPr kumimoji="0" lang="en-US" b="1" i="0" u="none" strike="noStrike" kern="1200" cap="none" spc="0" normalizeH="0" baseline="0" noProof="0" dirty="0">
+                  <a:ln>
+                    <a:noFill/>
+                  </a:ln>
+                  <a:solidFill>
+                    <a:srgbClr val="FFFFFF"/>
+                  </a:solidFill>
+                  <a:effectLst/>
+                  <a:uLnTx/>
+                  <a:uFillTx/>
+                  <a:latin typeface="Source Sans Pro" panose="020B0503030403020204" pitchFamily="34" charset="0"/>
+                  <a:ea typeface="Source Sans Pro" panose="020B0503030403020204" pitchFamily="34" charset="0"/>
+                </a:rPr>
+                <a:t>Report</a:t>
+              </a:r>
+            </a:p>
+          </p:txBody>
+        </p:sp>
+        <p:sp>
+          <p:nvSpPr>
+            <p:cNvPr id="7" name="TextBox 6">
+              <a:extLst>
+                <a:ext uri="{FF2B5EF4-FFF2-40B4-BE49-F238E27FC236}">
+                  <a16:creationId xmlns:a16="http://schemas.microsoft.com/office/drawing/2014/main" id="{B23A0830-C33A-05D8-4E0B-CC5D280FBC65}"/>
+                </a:ext>
+              </a:extLst>
+            </p:cNvPr>
+            <p:cNvSpPr txBox="1"/>
+            <p:nvPr/>
+          </p:nvSpPr>
+          <p:spPr>
+            <a:xfrm rot="3674562">
+              <a:off x="287795" y="4653497"/>
+              <a:ext cx="1453896" cy="523220"/>
+            </a:xfrm>
+            <a:prstGeom prst="rect">
+              <a:avLst/>
+            </a:prstGeom>
+            <a:noFill/>
+          </p:spPr>
+          <p:txBody>
+            <a:bodyPr wrap="none" rtlCol="0">
+              <a:prstTxWarp prst="textArchDown">
+                <a:avLst/>
+              </a:prstTxWarp>
+              <a:spAutoFit/>
+            </a:bodyPr>
+            <a:lstStyle/>
+            <a:p>
+              <a:pPr marL="0" marR="0" lvl="0" indent="0" algn="ctr" defTabSz="914400" rtl="0" eaLnBrk="1" fontAlgn="auto" latinLnBrk="0" hangingPunct="1">
+                <a:lnSpc>
+                  <a:spcPct val="100000"/>
+                </a:lnSpc>
+                <a:spcBef>
+                  <a:spcPts val="0"/>
+                </a:spcBef>
+                <a:spcAft>
+                  <a:spcPts val="0"/>
+                </a:spcAft>
+                <a:buClrTx/>
+                <a:buSzTx/>
+                <a:buFontTx/>
+                <a:buNone/>
+                <a:tabLst/>
+                <a:defRPr/>
+              </a:pPr>
+              <a:r>
+                <a:rPr kumimoji="0" lang="en-US" b="1" i="0" u="none" strike="noStrike" kern="1200" cap="none" spc="0" normalizeH="0" baseline="0" noProof="0">
+                  <a:ln>
+                    <a:noFill/>
+                  </a:ln>
+                  <a:solidFill>
+                    <a:srgbClr val="FFFFFF"/>
+                  </a:solidFill>
+                  <a:effectLst/>
+                  <a:uLnTx/>
+                  <a:uFillTx/>
+                  <a:latin typeface="Source Sans Pro" panose="020B0503030403020204" pitchFamily="34" charset="0"/>
+                  <a:ea typeface="Source Sans Pro" panose="020B0503030403020204" pitchFamily="34" charset="0"/>
+                </a:rPr>
+                <a:t>Test</a:t>
+              </a:r>
+            </a:p>
+          </p:txBody>
+        </p:sp>
+        <p:sp>
+          <p:nvSpPr>
+            <p:cNvPr id="8" name="TextBox 7">
+              <a:extLst>
+                <a:ext uri="{FF2B5EF4-FFF2-40B4-BE49-F238E27FC236}">
+                  <a16:creationId xmlns:a16="http://schemas.microsoft.com/office/drawing/2014/main" id="{49EEB8E6-82E3-D8B3-9D41-AC988F8021CB}"/>
+                </a:ext>
+              </a:extLst>
+            </p:cNvPr>
+            <p:cNvSpPr txBox="1"/>
+            <p:nvPr/>
+          </p:nvSpPr>
+          <p:spPr>
+            <a:xfrm>
+              <a:off x="5103940" y="2961624"/>
+              <a:ext cx="1455847" cy="523220"/>
+            </a:xfrm>
+            <a:prstGeom prst="rect">
+              <a:avLst/>
+            </a:prstGeom>
+            <a:noFill/>
+          </p:spPr>
+          <p:txBody>
+            <a:bodyPr wrap="none" rtlCol="0">
+              <a:prstTxWarp prst="textArchUp">
+                <a:avLst/>
+              </a:prstTxWarp>
+              <a:spAutoFit/>
+            </a:bodyPr>
+            <a:lstStyle/>
+            <a:p>
+              <a:pPr marL="0" marR="0" lvl="0" indent="0" algn="ctr" defTabSz="914400" rtl="0" eaLnBrk="1" fontAlgn="auto" latinLnBrk="0" hangingPunct="1">
+                <a:lnSpc>
+                  <a:spcPct val="100000"/>
+                </a:lnSpc>
+                <a:spcBef>
+                  <a:spcPts val="0"/>
+                </a:spcBef>
+                <a:spcAft>
+                  <a:spcPts val="0"/>
+                </a:spcAft>
+                <a:buClrTx/>
+                <a:buSzTx/>
+                <a:buFontTx/>
+                <a:buNone/>
+                <a:tabLst/>
+                <a:defRPr/>
+              </a:pPr>
+              <a:r>
+                <a:rPr kumimoji="0" lang="en-US" b="1" i="0" u="none" strike="noStrike" kern="1200" cap="none" spc="0" normalizeH="0" baseline="0" noProof="0">
+                  <a:ln>
+                    <a:noFill/>
+                  </a:ln>
+                  <a:solidFill>
+                    <a:srgbClr val="FFFFFF"/>
+                  </a:solidFill>
+                  <a:effectLst/>
+                  <a:uLnTx/>
+                  <a:uFillTx/>
+                  <a:latin typeface="Source Sans Pro" panose="020B0503030403020204" pitchFamily="34" charset="0"/>
+                  <a:ea typeface="Source Sans Pro" panose="020B0503030403020204" pitchFamily="34" charset="0"/>
+                </a:rPr>
+                <a:t>Release</a:t>
+              </a:r>
+            </a:p>
+          </p:txBody>
+        </p:sp>
+        <p:sp>
+          <p:nvSpPr>
+            <p:cNvPr id="9" name="TextBox 8">
+              <a:extLst>
+                <a:ext uri="{FF2B5EF4-FFF2-40B4-BE49-F238E27FC236}">
+                  <a16:creationId xmlns:a16="http://schemas.microsoft.com/office/drawing/2014/main" id="{566B5D55-89E9-C623-4189-47B12E6A1C31}"/>
+                </a:ext>
+              </a:extLst>
+            </p:cNvPr>
+            <p:cNvSpPr txBox="1"/>
+            <p:nvPr/>
+          </p:nvSpPr>
+          <p:spPr>
+            <a:xfrm rot="17849146">
+              <a:off x="6216226" y="4520797"/>
+              <a:ext cx="1453896" cy="701411"/>
+            </a:xfrm>
+            <a:prstGeom prst="rect">
+              <a:avLst/>
+            </a:prstGeom>
+            <a:noFill/>
+          </p:spPr>
+          <p:txBody>
+            <a:bodyPr wrap="none" rtlCol="0">
+              <a:prstTxWarp prst="textArchDown">
+                <a:avLst/>
+              </a:prstTxWarp>
+              <a:spAutoFit/>
+            </a:bodyPr>
+            <a:lstStyle/>
+            <a:p>
+              <a:pPr marL="0" marR="0" lvl="0" indent="0" algn="ctr" defTabSz="914400" rtl="0" eaLnBrk="1" fontAlgn="auto" latinLnBrk="0" hangingPunct="1">
+                <a:lnSpc>
+                  <a:spcPct val="100000"/>
+                </a:lnSpc>
+                <a:spcBef>
+                  <a:spcPts val="0"/>
+                </a:spcBef>
+                <a:spcAft>
+                  <a:spcPts val="0"/>
+                </a:spcAft>
+                <a:buClrTx/>
+                <a:buSzTx/>
+                <a:buFontTx/>
+                <a:buNone/>
+                <a:tabLst/>
+                <a:defRPr/>
+              </a:pPr>
+              <a:r>
+                <a:rPr kumimoji="0" lang="en-US" b="1" i="0" u="none" strike="noStrike" kern="1200" cap="none" spc="0" normalizeH="0" baseline="0" noProof="0">
+                  <a:ln>
+                    <a:noFill/>
+                  </a:ln>
+                  <a:solidFill>
+                    <a:srgbClr val="FFFFFF"/>
+                  </a:solidFill>
+                  <a:effectLst/>
+                  <a:uLnTx/>
+                  <a:uFillTx/>
+                  <a:latin typeface="Source Sans Pro" panose="020B0503030403020204" pitchFamily="34" charset="0"/>
+                  <a:ea typeface="Source Sans Pro" panose="020B0503030403020204" pitchFamily="34" charset="0"/>
+                </a:rPr>
+                <a:t>Run</a:t>
+              </a:r>
+            </a:p>
+          </p:txBody>
+        </p:sp>
+        <p:sp>
+          <p:nvSpPr>
+            <p:cNvPr id="10" name="TextBox 9">
+              <a:extLst>
+                <a:ext uri="{FF2B5EF4-FFF2-40B4-BE49-F238E27FC236}">
+                  <a16:creationId xmlns:a16="http://schemas.microsoft.com/office/drawing/2014/main" id="{89ED2AF6-CEAF-B8FD-305E-C362856DD96C}"/>
+                </a:ext>
+              </a:extLst>
+            </p:cNvPr>
+            <p:cNvSpPr txBox="1"/>
+            <p:nvPr/>
+          </p:nvSpPr>
+          <p:spPr>
+            <a:xfrm rot="2582550">
+              <a:off x="4120130" y="5093087"/>
+              <a:ext cx="1569660" cy="523220"/>
+            </a:xfrm>
+            <a:prstGeom prst="rect">
+              <a:avLst/>
+            </a:prstGeom>
+            <a:noFill/>
+          </p:spPr>
+          <p:txBody>
+            <a:bodyPr wrap="none" rtlCol="0">
+              <a:prstTxWarp prst="textArchDown">
+                <a:avLst/>
+              </a:prstTxWarp>
+              <a:spAutoFit/>
+            </a:bodyPr>
+            <a:lstStyle/>
+            <a:p>
+              <a:pPr marL="0" marR="0" lvl="0" indent="0" algn="ctr" defTabSz="914400" rtl="0" eaLnBrk="1" fontAlgn="auto" latinLnBrk="0" hangingPunct="1">
+                <a:lnSpc>
+                  <a:spcPct val="100000"/>
+                </a:lnSpc>
+                <a:spcBef>
+                  <a:spcPts val="0"/>
+                </a:spcBef>
+                <a:spcAft>
+                  <a:spcPts val="0"/>
+                </a:spcAft>
+                <a:buClrTx/>
+                <a:buSzTx/>
+                <a:buFontTx/>
+                <a:buNone/>
+                <a:tabLst/>
+                <a:defRPr/>
+              </a:pPr>
+              <a:r>
+                <a:rPr kumimoji="0" lang="en-US" b="1" i="0" u="none" strike="noStrike" kern="1200" cap="none" spc="0" normalizeH="0" baseline="0" noProof="0">
+                  <a:ln>
+                    <a:noFill/>
+                  </a:ln>
+                  <a:solidFill>
+                    <a:srgbClr val="FFFFFF"/>
+                  </a:solidFill>
+                  <a:effectLst/>
+                  <a:uLnTx/>
+                  <a:uFillTx/>
+                  <a:latin typeface="Source Sans Pro" panose="020B0503030403020204" pitchFamily="34" charset="0"/>
+                  <a:ea typeface="Source Sans Pro" panose="020B0503030403020204" pitchFamily="34" charset="0"/>
+                </a:rPr>
+                <a:t>Monitor</a:t>
+              </a:r>
+            </a:p>
+          </p:txBody>
+        </p:sp>
+      </p:grpSp>
+    </p:spTree>
+    <p:extLst>
+      <p:ext uri="{BB962C8B-B14F-4D97-AF65-F5344CB8AC3E}">
+        <p14:creationId xmlns:p14="http://schemas.microsoft.com/office/powerpoint/2010/main" val="1692443439"/>
+      </p:ext>
+    </p:extLst>
+  </p:cSld>
+  <p:clrMapOvr>
+    <a:masterClrMapping/>
+  </p:clrMapOvr>
+</p:sld>
+</file>
+
+<file path=ppt/slides/slide2.xml><?xml version="1.0" encoding="utf-8"?>
+<p:sld xmlns:a="http://schemas.openxmlformats.org/drawingml/2006/main" xmlns:r="http://schemas.openxmlformats.org/officeDocument/2006/relationships" xmlns:p="http://schemas.openxmlformats.org/presentationml/2006/main">
+  <p:cSld>
+    <p:spTree>
+      <p:nvGrpSpPr>
         <p:cNvPr id="1" name="">
           <a:extLst>
             <a:ext uri="{FF2B5EF4-FFF2-40B4-BE49-F238E27FC236}">
@@ -7799,7 +9535,1347 @@
 </p:sld>
 </file>
 
-<file path=ppt/slides/slide2.xml><?xml version="1.0" encoding="utf-8"?>
+<file path=ppt/slides/slide3.xml><?xml version="1.0" encoding="utf-8"?>
+<p:sld xmlns:a="http://schemas.openxmlformats.org/drawingml/2006/main" xmlns:r="http://schemas.openxmlformats.org/officeDocument/2006/relationships" xmlns:p="http://schemas.openxmlformats.org/presentationml/2006/main">
+  <p:cSld>
+    <p:spTree>
+      <p:nvGrpSpPr>
+        <p:cNvPr id="1" name="">
+          <a:extLst>
+            <a:ext uri="{FF2B5EF4-FFF2-40B4-BE49-F238E27FC236}">
+              <a16:creationId xmlns:a16="http://schemas.microsoft.com/office/drawing/2014/main" id="{89DF20AE-C106-3D2F-DF1A-855A5B350F57}"/>
+            </a:ext>
+          </a:extLst>
+        </p:cNvPr>
+        <p:cNvGrpSpPr/>
+        <p:nvPr/>
+      </p:nvGrpSpPr>
+      <p:grpSpPr>
+        <a:xfrm>
+          <a:off x="0" y="0"/>
+          <a:ext cx="0" cy="0"/>
+          <a:chOff x="0" y="0"/>
+          <a:chExt cx="0" cy="0"/>
+        </a:xfrm>
+      </p:grpSpPr>
+      <p:sp>
+        <p:nvSpPr>
+          <p:cNvPr id="26" name="Pentagon 25">
+            <a:extLst>
+              <a:ext uri="{FF2B5EF4-FFF2-40B4-BE49-F238E27FC236}">
+                <a16:creationId xmlns:a16="http://schemas.microsoft.com/office/drawing/2014/main" id="{9412E84A-3E9C-3526-25AD-143BF5D7ED97}"/>
+              </a:ext>
+            </a:extLst>
+          </p:cNvPr>
+          <p:cNvSpPr/>
+          <p:nvPr/>
+        </p:nvSpPr>
+        <p:spPr>
+          <a:xfrm>
+            <a:off x="3558095" y="1703282"/>
+            <a:ext cx="1144273" cy="298376"/>
+          </a:xfrm>
+          <a:prstGeom prst="homePlate">
+            <a:avLst/>
+          </a:prstGeom>
+          <a:solidFill>
+            <a:schemeClr val="accent2"/>
+          </a:solidFill>
+          <a:ln w="19050">
+            <a:solidFill>
+              <a:schemeClr val="accent4"/>
+            </a:solidFill>
+          </a:ln>
+          <a:effectLst/>
+        </p:spPr>
+        <p:style>
+          <a:lnRef idx="2">
+            <a:schemeClr val="accent1">
+              <a:shade val="50000"/>
+            </a:schemeClr>
+          </a:lnRef>
+          <a:fillRef idx="1">
+            <a:schemeClr val="accent1"/>
+          </a:fillRef>
+          <a:effectRef idx="0">
+            <a:schemeClr val="accent1"/>
+          </a:effectRef>
+          <a:fontRef idx="minor">
+            <a:schemeClr val="lt1"/>
+          </a:fontRef>
+        </p:style>
+        <p:txBody>
+          <a:bodyPr rtlCol="0" anchor="ctr"/>
+          <a:lstStyle/>
+          <a:p>
+            <a:pPr algn="ctr">
+              <a:lnSpc>
+                <a:spcPct val="95000"/>
+              </a:lnSpc>
+            </a:pPr>
+            <a:endParaRPr lang="en-US" b="1" dirty="0">
+              <a:solidFill>
+                <a:schemeClr val="tx2"/>
+              </a:solidFill>
+              <a:latin typeface="+mj-lt"/>
+            </a:endParaRPr>
+          </a:p>
+        </p:txBody>
+      </p:sp>
+      <p:sp>
+        <p:nvSpPr>
+          <p:cNvPr id="19" name="Circular Arrow 18">
+            <a:extLst>
+              <a:ext uri="{FF2B5EF4-FFF2-40B4-BE49-F238E27FC236}">
+                <a16:creationId xmlns:a16="http://schemas.microsoft.com/office/drawing/2014/main" id="{88FF63C5-8FDA-0E21-62AB-634982D1A3F5}"/>
+              </a:ext>
+            </a:extLst>
+          </p:cNvPr>
+          <p:cNvSpPr/>
+          <p:nvPr/>
+        </p:nvSpPr>
+        <p:spPr>
+          <a:xfrm rot="3355786" flipH="1">
+            <a:off x="3928835" y="95952"/>
+            <a:ext cx="1944772" cy="1945987"/>
+          </a:xfrm>
+          <a:prstGeom prst="circularArrow">
+            <a:avLst>
+              <a:gd name="adj1" fmla="val 15037"/>
+              <a:gd name="adj2" fmla="val 101784"/>
+              <a:gd name="adj3" fmla="val 19561631"/>
+              <a:gd name="adj4" fmla="val 11869509"/>
+              <a:gd name="adj5" fmla="val 8364"/>
+            </a:avLst>
+          </a:prstGeom>
+          <a:solidFill>
+            <a:srgbClr val="A44E3C"/>
+          </a:solidFill>
+          <a:ln w="19050">
+            <a:solidFill>
+              <a:schemeClr val="bg1"/>
+            </a:solidFill>
+          </a:ln>
+        </p:spPr>
+        <p:style>
+          <a:lnRef idx="0">
+            <a:scrgbClr r="0" g="0" b="0"/>
+          </a:lnRef>
+          <a:fillRef idx="0">
+            <a:scrgbClr r="0" g="0" b="0"/>
+          </a:fillRef>
+          <a:effectRef idx="0">
+            <a:scrgbClr r="0" g="0" b="0"/>
+          </a:effectRef>
+          <a:fontRef idx="minor">
+            <a:schemeClr val="lt1"/>
+          </a:fontRef>
+        </p:style>
+        <p:txBody>
+          <a:bodyPr rtlCol="0" anchor="ctr"/>
+          <a:lstStyle/>
+          <a:p>
+            <a:pPr marL="0" marR="0" lvl="0" indent="0" algn="ctr" defTabSz="914400" rtl="0" eaLnBrk="1" fontAlgn="auto" latinLnBrk="0" hangingPunct="1">
+              <a:lnSpc>
+                <a:spcPct val="95000"/>
+              </a:lnSpc>
+              <a:spcBef>
+                <a:spcPts val="0"/>
+              </a:spcBef>
+              <a:spcAft>
+                <a:spcPts val="0"/>
+              </a:spcAft>
+              <a:buClrTx/>
+              <a:buSzTx/>
+              <a:buFontTx/>
+              <a:buNone/>
+              <a:tabLst/>
+              <a:defRPr/>
+            </a:pPr>
+            <a:endParaRPr kumimoji="0" lang="en-US" sz="1800" b="1" i="0" u="none" strike="noStrike" kern="1200" cap="none" spc="0" normalizeH="0" baseline="0" noProof="0">
+              <a:ln>
+                <a:noFill/>
+              </a:ln>
+              <a:solidFill>
+                <a:srgbClr val="C9BC9B"/>
+              </a:solidFill>
+              <a:effectLst/>
+              <a:uLnTx/>
+              <a:uFillTx/>
+              <a:latin typeface="Source Sans Pro" panose="020B0503030403020204" pitchFamily="34" charset="0"/>
+              <a:ea typeface="Source Sans Pro" panose="020B0503030403020204" pitchFamily="34" charset="0"/>
+            </a:endParaRPr>
+          </a:p>
+        </p:txBody>
+      </p:sp>
+      <p:sp>
+        <p:nvSpPr>
+          <p:cNvPr id="17" name="Oval 16">
+            <a:extLst>
+              <a:ext uri="{FF2B5EF4-FFF2-40B4-BE49-F238E27FC236}">
+                <a16:creationId xmlns:a16="http://schemas.microsoft.com/office/drawing/2014/main" id="{AE82E54B-2EEA-C877-4836-6F6FA070CFA7}"/>
+              </a:ext>
+            </a:extLst>
+          </p:cNvPr>
+          <p:cNvSpPr/>
+          <p:nvPr/>
+        </p:nvSpPr>
+        <p:spPr>
+          <a:xfrm>
+            <a:off x="2034789" y="96561"/>
+            <a:ext cx="1888855" cy="1891085"/>
+          </a:xfrm>
+          <a:prstGeom prst="ellipse">
+            <a:avLst/>
+          </a:prstGeom>
+          <a:solidFill>
+            <a:schemeClr val="accent2"/>
+          </a:solidFill>
+          <a:ln>
+            <a:noFill/>
+          </a:ln>
+          <a:effectLst>
+            <a:outerShdw dist="38100" dir="5400000" algn="t" rotWithShape="0">
+              <a:schemeClr val="bg2">
+                <a:alpha val="20000"/>
+              </a:schemeClr>
+            </a:outerShdw>
+          </a:effectLst>
+        </p:spPr>
+        <p:style>
+          <a:lnRef idx="2">
+            <a:schemeClr val="accent1">
+              <a:shade val="50000"/>
+            </a:schemeClr>
+          </a:lnRef>
+          <a:fillRef idx="1">
+            <a:schemeClr val="accent1"/>
+          </a:fillRef>
+          <a:effectRef idx="0">
+            <a:schemeClr val="accent1"/>
+          </a:effectRef>
+          <a:fontRef idx="minor">
+            <a:schemeClr val="lt1"/>
+          </a:fontRef>
+        </p:style>
+        <p:txBody>
+          <a:bodyPr rtlCol="0" anchor="ctr"/>
+          <a:lstStyle/>
+          <a:p>
+            <a:pPr algn="ctr">
+              <a:lnSpc>
+                <a:spcPct val="95000"/>
+              </a:lnSpc>
+            </a:pPr>
+            <a:endParaRPr lang="en-US" b="1" dirty="0">
+              <a:solidFill>
+                <a:schemeClr val="tx2"/>
+              </a:solidFill>
+              <a:latin typeface="+mj-lt"/>
+            </a:endParaRPr>
+          </a:p>
+        </p:txBody>
+      </p:sp>
+      <p:sp>
+        <p:nvSpPr>
+          <p:cNvPr id="12" name="Circular Arrow 11">
+            <a:extLst>
+              <a:ext uri="{FF2B5EF4-FFF2-40B4-BE49-F238E27FC236}">
+                <a16:creationId xmlns:a16="http://schemas.microsoft.com/office/drawing/2014/main" id="{BD5EFFA1-CC37-58B4-F233-2FC5222D903F}"/>
+              </a:ext>
+            </a:extLst>
+          </p:cNvPr>
+          <p:cNvSpPr/>
+          <p:nvPr/>
+        </p:nvSpPr>
+        <p:spPr>
+          <a:xfrm rot="6395597" flipH="1">
+            <a:off x="3928836" y="95953"/>
+            <a:ext cx="1944772" cy="1945987"/>
+          </a:xfrm>
+          <a:prstGeom prst="circularArrow">
+            <a:avLst>
+              <a:gd name="adj1" fmla="val 15037"/>
+              <a:gd name="adj2" fmla="val 1142319"/>
+              <a:gd name="adj3" fmla="val 19561631"/>
+              <a:gd name="adj4" fmla="val 11869509"/>
+              <a:gd name="adj5" fmla="val 8364"/>
+            </a:avLst>
+          </a:prstGeom>
+          <a:solidFill>
+            <a:srgbClr val="A44E3C"/>
+          </a:solidFill>
+          <a:ln w="19050">
+            <a:solidFill>
+              <a:schemeClr val="bg1"/>
+            </a:solidFill>
+          </a:ln>
+        </p:spPr>
+        <p:style>
+          <a:lnRef idx="0">
+            <a:scrgbClr r="0" g="0" b="0"/>
+          </a:lnRef>
+          <a:fillRef idx="0">
+            <a:scrgbClr r="0" g="0" b="0"/>
+          </a:fillRef>
+          <a:effectRef idx="0">
+            <a:scrgbClr r="0" g="0" b="0"/>
+          </a:effectRef>
+          <a:fontRef idx="minor">
+            <a:schemeClr val="lt1"/>
+          </a:fontRef>
+        </p:style>
+        <p:txBody>
+          <a:bodyPr rtlCol="0" anchor="ctr"/>
+          <a:lstStyle/>
+          <a:p>
+            <a:pPr marL="0" marR="0" lvl="0" indent="0" algn="ctr" defTabSz="914400" rtl="0" eaLnBrk="1" fontAlgn="auto" latinLnBrk="0" hangingPunct="1">
+              <a:lnSpc>
+                <a:spcPct val="95000"/>
+              </a:lnSpc>
+              <a:spcBef>
+                <a:spcPts val="0"/>
+              </a:spcBef>
+              <a:spcAft>
+                <a:spcPts val="0"/>
+              </a:spcAft>
+              <a:buClrTx/>
+              <a:buSzTx/>
+              <a:buFontTx/>
+              <a:buNone/>
+              <a:tabLst/>
+              <a:defRPr/>
+            </a:pPr>
+            <a:endParaRPr kumimoji="0" lang="en-US" sz="1800" b="1" i="0" u="none" strike="noStrike" kern="1200" cap="none" spc="0" normalizeH="0" baseline="0" noProof="0">
+              <a:ln>
+                <a:noFill/>
+              </a:ln>
+              <a:solidFill>
+                <a:srgbClr val="C9BC9B"/>
+              </a:solidFill>
+              <a:effectLst/>
+              <a:uLnTx/>
+              <a:uFillTx/>
+              <a:latin typeface="Source Sans Pro" panose="020B0503030403020204" pitchFamily="34" charset="0"/>
+              <a:ea typeface="Source Sans Pro" panose="020B0503030403020204" pitchFamily="34" charset="0"/>
+            </a:endParaRPr>
+          </a:p>
+        </p:txBody>
+      </p:sp>
+      <p:sp>
+        <p:nvSpPr>
+          <p:cNvPr id="5" name="TextBox 4">
+            <a:extLst>
+              <a:ext uri="{FF2B5EF4-FFF2-40B4-BE49-F238E27FC236}">
+                <a16:creationId xmlns:a16="http://schemas.microsoft.com/office/drawing/2014/main" id="{5813CB7C-759D-48C3-F683-B57A0BBAEBAE}"/>
+              </a:ext>
+            </a:extLst>
+          </p:cNvPr>
+          <p:cNvSpPr txBox="1"/>
+          <p:nvPr/>
+        </p:nvSpPr>
+        <p:spPr>
+          <a:xfrm>
+            <a:off x="2579784" y="291098"/>
+            <a:ext cx="780703" cy="280955"/>
+          </a:xfrm>
+          <a:prstGeom prst="rect">
+            <a:avLst/>
+          </a:prstGeom>
+          <a:noFill/>
+        </p:spPr>
+        <p:txBody>
+          <a:bodyPr wrap="none" rtlCol="0">
+            <a:prstTxWarp prst="textArchUp">
+              <a:avLst/>
+            </a:prstTxWarp>
+            <a:spAutoFit/>
+          </a:bodyPr>
+          <a:lstStyle/>
+          <a:p>
+            <a:pPr marL="0" marR="0" lvl="0" indent="0" algn="ctr" defTabSz="914400" rtl="0" eaLnBrk="1" fontAlgn="auto" latinLnBrk="0" hangingPunct="1">
+              <a:lnSpc>
+                <a:spcPct val="100000"/>
+              </a:lnSpc>
+              <a:spcBef>
+                <a:spcPts val="0"/>
+              </a:spcBef>
+              <a:spcAft>
+                <a:spcPts val="0"/>
+              </a:spcAft>
+              <a:buClrTx/>
+              <a:buSzTx/>
+              <a:buFontTx/>
+              <a:buNone/>
+              <a:tabLst/>
+              <a:defRPr/>
+            </a:pPr>
+            <a:r>
+              <a:rPr kumimoji="0" lang="en-US" b="1" i="0" u="none" strike="noStrike" kern="1200" cap="none" spc="0" normalizeH="0" baseline="0" noProof="0" dirty="0">
+                <a:ln>
+                  <a:noFill/>
+                </a:ln>
+                <a:solidFill>
+                  <a:srgbClr val="FFFFFF"/>
+                </a:solidFill>
+                <a:effectLst/>
+                <a:uLnTx/>
+                <a:uFillTx/>
+                <a:latin typeface="Source Sans Pro" panose="020B0503030403020204" pitchFamily="34" charset="0"/>
+                <a:ea typeface="Source Sans Pro" panose="020B0503030403020204" pitchFamily="34" charset="0"/>
+              </a:rPr>
+              <a:t>Curate</a:t>
+            </a:r>
+          </a:p>
+        </p:txBody>
+      </p:sp>
+      <p:sp>
+        <p:nvSpPr>
+          <p:cNvPr id="6" name="TextBox 5">
+            <a:extLst>
+              <a:ext uri="{FF2B5EF4-FFF2-40B4-BE49-F238E27FC236}">
+                <a16:creationId xmlns:a16="http://schemas.microsoft.com/office/drawing/2014/main" id="{8C548B02-4BE5-8041-9FB7-0447C912E37E}"/>
+              </a:ext>
+            </a:extLst>
+          </p:cNvPr>
+          <p:cNvSpPr txBox="1"/>
+          <p:nvPr/>
+        </p:nvSpPr>
+        <p:spPr>
+          <a:xfrm rot="19017958">
+            <a:off x="2994623" y="1431257"/>
+            <a:ext cx="844534" cy="280955"/>
+          </a:xfrm>
+          <a:prstGeom prst="rect">
+            <a:avLst/>
+          </a:prstGeom>
+          <a:noFill/>
+        </p:spPr>
+        <p:txBody>
+          <a:bodyPr wrap="none" rtlCol="0">
+            <a:prstTxWarp prst="textArchDown">
+              <a:avLst/>
+            </a:prstTxWarp>
+            <a:spAutoFit/>
+          </a:bodyPr>
+          <a:lstStyle/>
+          <a:p>
+            <a:pPr marL="0" marR="0" lvl="0" indent="0" algn="ctr" defTabSz="914400" rtl="0" eaLnBrk="1" fontAlgn="auto" latinLnBrk="0" hangingPunct="1">
+              <a:lnSpc>
+                <a:spcPct val="100000"/>
+              </a:lnSpc>
+              <a:spcBef>
+                <a:spcPts val="0"/>
+              </a:spcBef>
+              <a:spcAft>
+                <a:spcPts val="0"/>
+              </a:spcAft>
+              <a:buClrTx/>
+              <a:buSzTx/>
+              <a:buFontTx/>
+              <a:buNone/>
+              <a:tabLst/>
+              <a:defRPr/>
+            </a:pPr>
+            <a:r>
+              <a:rPr kumimoji="0" lang="en-US" b="1" i="0" u="none" strike="noStrike" kern="1200" cap="none" spc="0" normalizeH="0" baseline="0" noProof="0" dirty="0">
+                <a:ln>
+                  <a:noFill/>
+                </a:ln>
+                <a:solidFill>
+                  <a:srgbClr val="FFFFFF"/>
+                </a:solidFill>
+                <a:effectLst/>
+                <a:uLnTx/>
+                <a:uFillTx/>
+                <a:latin typeface="Source Sans Pro" panose="020B0503030403020204" pitchFamily="34" charset="0"/>
+                <a:ea typeface="Source Sans Pro" panose="020B0503030403020204" pitchFamily="34" charset="0"/>
+              </a:rPr>
+              <a:t>Report</a:t>
+            </a:r>
+          </a:p>
+        </p:txBody>
+      </p:sp>
+      <p:sp>
+        <p:nvSpPr>
+          <p:cNvPr id="7" name="TextBox 6">
+            <a:extLst>
+              <a:ext uri="{FF2B5EF4-FFF2-40B4-BE49-F238E27FC236}">
+                <a16:creationId xmlns:a16="http://schemas.microsoft.com/office/drawing/2014/main" id="{DC818689-BE32-C8B0-E6A2-DA108F48A77D}"/>
+              </a:ext>
+            </a:extLst>
+          </p:cNvPr>
+          <p:cNvSpPr txBox="1"/>
+          <p:nvPr/>
+        </p:nvSpPr>
+        <p:spPr>
+          <a:xfrm rot="3674562">
+            <a:off x="1926150" y="1195746"/>
+            <a:ext cx="780703" cy="280955"/>
+          </a:xfrm>
+          <a:prstGeom prst="rect">
+            <a:avLst/>
+          </a:prstGeom>
+          <a:noFill/>
+        </p:spPr>
+        <p:txBody>
+          <a:bodyPr wrap="none" rtlCol="0">
+            <a:prstTxWarp prst="textArchDown">
+              <a:avLst/>
+            </a:prstTxWarp>
+            <a:spAutoFit/>
+          </a:bodyPr>
+          <a:lstStyle/>
+          <a:p>
+            <a:pPr marL="0" marR="0" lvl="0" indent="0" algn="ctr" defTabSz="914400" rtl="0" eaLnBrk="1" fontAlgn="auto" latinLnBrk="0" hangingPunct="1">
+              <a:lnSpc>
+                <a:spcPct val="100000"/>
+              </a:lnSpc>
+              <a:spcBef>
+                <a:spcPts val="0"/>
+              </a:spcBef>
+              <a:spcAft>
+                <a:spcPts val="0"/>
+              </a:spcAft>
+              <a:buClrTx/>
+              <a:buSzTx/>
+              <a:buFontTx/>
+              <a:buNone/>
+              <a:tabLst/>
+              <a:defRPr/>
+            </a:pPr>
+            <a:r>
+              <a:rPr kumimoji="0" lang="en-US" b="1" i="0" u="none" strike="noStrike" kern="1200" cap="none" spc="0" normalizeH="0" baseline="0" noProof="0" dirty="0">
+                <a:ln>
+                  <a:noFill/>
+                </a:ln>
+                <a:solidFill>
+                  <a:srgbClr val="FFFFFF"/>
+                </a:solidFill>
+                <a:effectLst/>
+                <a:uLnTx/>
+                <a:uFillTx/>
+                <a:latin typeface="Source Sans Pro" panose="020B0503030403020204" pitchFamily="34" charset="0"/>
+                <a:ea typeface="Source Sans Pro" panose="020B0503030403020204" pitchFamily="34" charset="0"/>
+              </a:rPr>
+              <a:t>Test</a:t>
+            </a:r>
+          </a:p>
+        </p:txBody>
+      </p:sp>
+      <p:sp>
+        <p:nvSpPr>
+          <p:cNvPr id="8" name="TextBox 7">
+            <a:extLst>
+              <a:ext uri="{FF2B5EF4-FFF2-40B4-BE49-F238E27FC236}">
+                <a16:creationId xmlns:a16="http://schemas.microsoft.com/office/drawing/2014/main" id="{C255C8B2-069D-D8EA-15B7-FE9CAFBCF7F0}"/>
+              </a:ext>
+            </a:extLst>
+          </p:cNvPr>
+          <p:cNvSpPr txBox="1"/>
+          <p:nvPr/>
+        </p:nvSpPr>
+        <p:spPr>
+          <a:xfrm>
+            <a:off x="4512291" y="287256"/>
+            <a:ext cx="781751" cy="280955"/>
+          </a:xfrm>
+          <a:prstGeom prst="rect">
+            <a:avLst/>
+          </a:prstGeom>
+          <a:noFill/>
+        </p:spPr>
+        <p:txBody>
+          <a:bodyPr wrap="none" rtlCol="0">
+            <a:prstTxWarp prst="textArchUp">
+              <a:avLst/>
+            </a:prstTxWarp>
+            <a:spAutoFit/>
+          </a:bodyPr>
+          <a:lstStyle/>
+          <a:p>
+            <a:pPr marL="0" marR="0" lvl="0" indent="0" algn="ctr" defTabSz="914400" rtl="0" eaLnBrk="1" fontAlgn="auto" latinLnBrk="0" hangingPunct="1">
+              <a:lnSpc>
+                <a:spcPct val="100000"/>
+              </a:lnSpc>
+              <a:spcBef>
+                <a:spcPts val="0"/>
+              </a:spcBef>
+              <a:spcAft>
+                <a:spcPts val="0"/>
+              </a:spcAft>
+              <a:buClrTx/>
+              <a:buSzTx/>
+              <a:buFontTx/>
+              <a:buNone/>
+              <a:tabLst/>
+              <a:defRPr/>
+            </a:pPr>
+            <a:r>
+              <a:rPr kumimoji="0" lang="en-US" b="1" i="0" u="none" strike="noStrike" kern="1200" cap="none" spc="0" normalizeH="0" baseline="0" noProof="0" dirty="0">
+                <a:ln>
+                  <a:noFill/>
+                </a:ln>
+                <a:solidFill>
+                  <a:srgbClr val="FFFFFF"/>
+                </a:solidFill>
+                <a:effectLst/>
+                <a:uLnTx/>
+                <a:uFillTx/>
+                <a:latin typeface="Source Sans Pro" panose="020B0503030403020204" pitchFamily="34" charset="0"/>
+                <a:ea typeface="Source Sans Pro" panose="020B0503030403020204" pitchFamily="34" charset="0"/>
+              </a:rPr>
+              <a:t>Release</a:t>
+            </a:r>
+          </a:p>
+        </p:txBody>
+      </p:sp>
+      <p:sp>
+        <p:nvSpPr>
+          <p:cNvPr id="9" name="TextBox 8">
+            <a:extLst>
+              <a:ext uri="{FF2B5EF4-FFF2-40B4-BE49-F238E27FC236}">
+                <a16:creationId xmlns:a16="http://schemas.microsoft.com/office/drawing/2014/main" id="{8FD278A3-4D89-2BD1-A327-6778E2EDF773}"/>
+              </a:ext>
+            </a:extLst>
+          </p:cNvPr>
+          <p:cNvSpPr txBox="1"/>
+          <p:nvPr/>
+        </p:nvSpPr>
+        <p:spPr>
+          <a:xfrm rot="16200000">
+            <a:off x="5160302" y="957162"/>
+            <a:ext cx="780703" cy="376639"/>
+          </a:xfrm>
+          <a:prstGeom prst="rect">
+            <a:avLst/>
+          </a:prstGeom>
+          <a:noFill/>
+        </p:spPr>
+        <p:txBody>
+          <a:bodyPr wrap="none" rtlCol="0">
+            <a:prstTxWarp prst="textArchDown">
+              <a:avLst/>
+            </a:prstTxWarp>
+            <a:spAutoFit/>
+          </a:bodyPr>
+          <a:lstStyle/>
+          <a:p>
+            <a:pPr marL="0" marR="0" lvl="0" indent="0" algn="ctr" defTabSz="914400" rtl="0" eaLnBrk="1" fontAlgn="auto" latinLnBrk="0" hangingPunct="1">
+              <a:lnSpc>
+                <a:spcPct val="100000"/>
+              </a:lnSpc>
+              <a:spcBef>
+                <a:spcPts val="0"/>
+              </a:spcBef>
+              <a:spcAft>
+                <a:spcPts val="0"/>
+              </a:spcAft>
+              <a:buClrTx/>
+              <a:buSzTx/>
+              <a:buFontTx/>
+              <a:buNone/>
+              <a:tabLst/>
+              <a:defRPr/>
+            </a:pPr>
+            <a:r>
+              <a:rPr kumimoji="0" lang="en-US" b="1" i="0" u="none" strike="noStrike" kern="1200" cap="none" spc="0" normalizeH="0" baseline="0" noProof="0" dirty="0">
+                <a:ln>
+                  <a:noFill/>
+                </a:ln>
+                <a:solidFill>
+                  <a:srgbClr val="FFFFFF"/>
+                </a:solidFill>
+                <a:effectLst/>
+                <a:uLnTx/>
+                <a:uFillTx/>
+                <a:latin typeface="Source Sans Pro" panose="020B0503030403020204" pitchFamily="34" charset="0"/>
+                <a:ea typeface="Source Sans Pro" panose="020B0503030403020204" pitchFamily="34" charset="0"/>
+              </a:rPr>
+              <a:t>Run</a:t>
+            </a:r>
+          </a:p>
+        </p:txBody>
+      </p:sp>
+      <p:sp>
+        <p:nvSpPr>
+          <p:cNvPr id="10" name="TextBox 9">
+            <a:extLst>
+              <a:ext uri="{FF2B5EF4-FFF2-40B4-BE49-F238E27FC236}">
+                <a16:creationId xmlns:a16="http://schemas.microsoft.com/office/drawing/2014/main" id="{FA9B96CE-BE8A-0C17-4E20-1E22A852C2EC}"/>
+              </a:ext>
+            </a:extLst>
+          </p:cNvPr>
+          <p:cNvSpPr txBox="1"/>
+          <p:nvPr/>
+        </p:nvSpPr>
+        <p:spPr>
+          <a:xfrm rot="415115">
+            <a:off x="4242680" y="1619264"/>
+            <a:ext cx="842865" cy="280955"/>
+          </a:xfrm>
+          <a:prstGeom prst="rect">
+            <a:avLst/>
+          </a:prstGeom>
+          <a:noFill/>
+        </p:spPr>
+        <p:txBody>
+          <a:bodyPr wrap="none" rtlCol="0">
+            <a:prstTxWarp prst="textArchDown">
+              <a:avLst/>
+            </a:prstTxWarp>
+            <a:spAutoFit/>
+          </a:bodyPr>
+          <a:lstStyle/>
+          <a:p>
+            <a:pPr marL="0" marR="0" lvl="0" indent="0" algn="ctr" defTabSz="914400" rtl="0" eaLnBrk="1" fontAlgn="auto" latinLnBrk="0" hangingPunct="1">
+              <a:lnSpc>
+                <a:spcPct val="100000"/>
+              </a:lnSpc>
+              <a:spcBef>
+                <a:spcPts val="0"/>
+              </a:spcBef>
+              <a:spcAft>
+                <a:spcPts val="0"/>
+              </a:spcAft>
+              <a:buClrTx/>
+              <a:buSzTx/>
+              <a:buFontTx/>
+              <a:buNone/>
+              <a:tabLst/>
+              <a:defRPr/>
+            </a:pPr>
+            <a:r>
+              <a:rPr kumimoji="0" lang="en-US" b="1" i="0" u="none" strike="noStrike" kern="1200" cap="none" spc="0" normalizeH="0" baseline="0" noProof="0" dirty="0">
+                <a:ln>
+                  <a:noFill/>
+                </a:ln>
+                <a:solidFill>
+                  <a:srgbClr val="FFFFFF"/>
+                </a:solidFill>
+                <a:effectLst/>
+                <a:uLnTx/>
+                <a:uFillTx/>
+                <a:latin typeface="Source Sans Pro" panose="020B0503030403020204" pitchFamily="34" charset="0"/>
+                <a:ea typeface="Source Sans Pro" panose="020B0503030403020204" pitchFamily="34" charset="0"/>
+              </a:rPr>
+              <a:t>Monitor</a:t>
+            </a:r>
+          </a:p>
+        </p:txBody>
+      </p:sp>
+      <p:sp>
+        <p:nvSpPr>
+          <p:cNvPr id="18" name="Circular Arrow 17">
+            <a:extLst>
+              <a:ext uri="{FF2B5EF4-FFF2-40B4-BE49-F238E27FC236}">
+                <a16:creationId xmlns:a16="http://schemas.microsoft.com/office/drawing/2014/main" id="{6E5451F4-E901-366F-CEB5-3213F4C511E5}"/>
+              </a:ext>
+            </a:extLst>
+          </p:cNvPr>
+          <p:cNvSpPr/>
+          <p:nvPr/>
+        </p:nvSpPr>
+        <p:spPr>
+          <a:xfrm flipH="1">
+            <a:off x="2006830" y="69109"/>
+            <a:ext cx="1944772" cy="1945987"/>
+          </a:xfrm>
+          <a:prstGeom prst="circularArrow">
+            <a:avLst>
+              <a:gd name="adj1" fmla="val 15037"/>
+              <a:gd name="adj2" fmla="val 1142319"/>
+              <a:gd name="adj3" fmla="val 19561631"/>
+              <a:gd name="adj4" fmla="val 10812040"/>
+              <a:gd name="adj5" fmla="val 8364"/>
+            </a:avLst>
+          </a:prstGeom>
+          <a:solidFill>
+            <a:srgbClr val="3E6D6F"/>
+          </a:solidFill>
+          <a:ln w="19050">
+            <a:solidFill>
+              <a:schemeClr val="bg1"/>
+            </a:solidFill>
+          </a:ln>
+        </p:spPr>
+        <p:style>
+          <a:lnRef idx="0">
+            <a:scrgbClr r="0" g="0" b="0"/>
+          </a:lnRef>
+          <a:fillRef idx="0">
+            <a:scrgbClr r="0" g="0" b="0"/>
+          </a:fillRef>
+          <a:effectRef idx="0">
+            <a:scrgbClr r="0" g="0" b="0"/>
+          </a:effectRef>
+          <a:fontRef idx="minor">
+            <a:schemeClr val="lt1"/>
+          </a:fontRef>
+        </p:style>
+        <p:txBody>
+          <a:bodyPr rtlCol="0" anchor="ctr"/>
+          <a:lstStyle/>
+          <a:p>
+            <a:pPr marL="0" marR="0" lvl="0" indent="0" algn="ctr" defTabSz="914400" rtl="0" eaLnBrk="1" fontAlgn="auto" latinLnBrk="0" hangingPunct="1">
+              <a:lnSpc>
+                <a:spcPct val="95000"/>
+              </a:lnSpc>
+              <a:spcBef>
+                <a:spcPts val="0"/>
+              </a:spcBef>
+              <a:spcAft>
+                <a:spcPts val="0"/>
+              </a:spcAft>
+              <a:buClrTx/>
+              <a:buSzTx/>
+              <a:buFontTx/>
+              <a:buNone/>
+              <a:tabLst/>
+              <a:defRPr/>
+            </a:pPr>
+            <a:endParaRPr kumimoji="0" lang="en-US" sz="1800" b="1" i="0" u="none" strike="noStrike" kern="1200" cap="none" spc="0" normalizeH="0" baseline="0" noProof="0">
+              <a:ln>
+                <a:noFill/>
+              </a:ln>
+              <a:solidFill>
+                <a:srgbClr val="C9BC9B"/>
+              </a:solidFill>
+              <a:effectLst/>
+              <a:uLnTx/>
+              <a:uFillTx/>
+              <a:latin typeface="Source Sans Pro" panose="020B0503030403020204" pitchFamily="34" charset="0"/>
+              <a:ea typeface="Source Sans Pro" panose="020B0503030403020204" pitchFamily="34" charset="0"/>
+            </a:endParaRPr>
+          </a:p>
+        </p:txBody>
+      </p:sp>
+      <p:sp>
+        <p:nvSpPr>
+          <p:cNvPr id="20" name="Circular Arrow 19">
+            <a:extLst>
+              <a:ext uri="{FF2B5EF4-FFF2-40B4-BE49-F238E27FC236}">
+                <a16:creationId xmlns:a16="http://schemas.microsoft.com/office/drawing/2014/main" id="{D1F4F7D5-6849-AFE3-75CE-723B45532E7C}"/>
+              </a:ext>
+            </a:extLst>
+          </p:cNvPr>
+          <p:cNvSpPr/>
+          <p:nvPr/>
+        </p:nvSpPr>
+        <p:spPr>
+          <a:xfrm rot="8267134" flipH="1">
+            <a:off x="2019844" y="69112"/>
+            <a:ext cx="1944772" cy="1945987"/>
+          </a:xfrm>
+          <a:prstGeom prst="circularArrow">
+            <a:avLst>
+              <a:gd name="adj1" fmla="val 15037"/>
+              <a:gd name="adj2" fmla="val 1142319"/>
+              <a:gd name="adj3" fmla="val 19561631"/>
+              <a:gd name="adj4" fmla="val 12438665"/>
+              <a:gd name="adj5" fmla="val 8364"/>
+            </a:avLst>
+          </a:prstGeom>
+          <a:solidFill>
+            <a:srgbClr val="3E6D6F"/>
+          </a:solidFill>
+          <a:ln w="19050">
+            <a:solidFill>
+              <a:schemeClr val="tx1"/>
+            </a:solidFill>
+          </a:ln>
+        </p:spPr>
+        <p:style>
+          <a:lnRef idx="0">
+            <a:scrgbClr r="0" g="0" b="0"/>
+          </a:lnRef>
+          <a:fillRef idx="0">
+            <a:scrgbClr r="0" g="0" b="0"/>
+          </a:fillRef>
+          <a:effectRef idx="0">
+            <a:scrgbClr r="0" g="0" b="0"/>
+          </a:effectRef>
+          <a:fontRef idx="minor">
+            <a:schemeClr val="lt1"/>
+          </a:fontRef>
+        </p:style>
+        <p:txBody>
+          <a:bodyPr rtlCol="0" anchor="ctr"/>
+          <a:lstStyle/>
+          <a:p>
+            <a:pPr marL="0" marR="0" lvl="0" indent="0" algn="ctr" defTabSz="914400" rtl="0" eaLnBrk="1" fontAlgn="auto" latinLnBrk="0" hangingPunct="1">
+              <a:lnSpc>
+                <a:spcPct val="95000"/>
+              </a:lnSpc>
+              <a:spcBef>
+                <a:spcPts val="0"/>
+              </a:spcBef>
+              <a:spcAft>
+                <a:spcPts val="0"/>
+              </a:spcAft>
+              <a:buClrTx/>
+              <a:buSzTx/>
+              <a:buFontTx/>
+              <a:buNone/>
+              <a:tabLst/>
+              <a:defRPr/>
+            </a:pPr>
+            <a:endParaRPr kumimoji="0" lang="en-US" sz="1800" b="1" i="0" u="none" strike="noStrike" kern="1200" cap="none" spc="0" normalizeH="0" baseline="0" noProof="0">
+              <a:ln>
+                <a:noFill/>
+              </a:ln>
+              <a:solidFill>
+                <a:srgbClr val="C9BC9B"/>
+              </a:solidFill>
+              <a:effectLst/>
+              <a:uLnTx/>
+              <a:uFillTx/>
+              <a:latin typeface="Source Sans Pro" panose="020B0503030403020204" pitchFamily="34" charset="0"/>
+              <a:ea typeface="Source Sans Pro" panose="020B0503030403020204" pitchFamily="34" charset="0"/>
+            </a:endParaRPr>
+          </a:p>
+        </p:txBody>
+      </p:sp>
+      <p:sp>
+        <p:nvSpPr>
+          <p:cNvPr id="15" name="Circular Arrow 14">
+            <a:extLst>
+              <a:ext uri="{FF2B5EF4-FFF2-40B4-BE49-F238E27FC236}">
+                <a16:creationId xmlns:a16="http://schemas.microsoft.com/office/drawing/2014/main" id="{9F0CAD7A-572E-FD75-B46D-2D5252695FC1}"/>
+              </a:ext>
+            </a:extLst>
+          </p:cNvPr>
+          <p:cNvSpPr/>
+          <p:nvPr/>
+        </p:nvSpPr>
+        <p:spPr>
+          <a:xfrm rot="15594126" flipH="1">
+            <a:off x="2010900" y="69111"/>
+            <a:ext cx="1944772" cy="1945987"/>
+          </a:xfrm>
+          <a:prstGeom prst="circularArrow">
+            <a:avLst>
+              <a:gd name="adj1" fmla="val 15037"/>
+              <a:gd name="adj2" fmla="val 1142319"/>
+              <a:gd name="adj3" fmla="val 19561631"/>
+              <a:gd name="adj4" fmla="val 13651316"/>
+              <a:gd name="adj5" fmla="val 8364"/>
+            </a:avLst>
+          </a:prstGeom>
+          <a:solidFill>
+            <a:srgbClr val="3E6D6F"/>
+          </a:solidFill>
+          <a:ln w="19050">
+            <a:solidFill>
+              <a:schemeClr val="bg1"/>
+            </a:solidFill>
+          </a:ln>
+        </p:spPr>
+        <p:style>
+          <a:lnRef idx="0">
+            <a:scrgbClr r="0" g="0" b="0"/>
+          </a:lnRef>
+          <a:fillRef idx="0">
+            <a:scrgbClr r="0" g="0" b="0"/>
+          </a:fillRef>
+          <a:effectRef idx="0">
+            <a:scrgbClr r="0" g="0" b="0"/>
+          </a:effectRef>
+          <a:fontRef idx="minor">
+            <a:schemeClr val="lt1"/>
+          </a:fontRef>
+        </p:style>
+        <p:txBody>
+          <a:bodyPr rtlCol="0" anchor="ctr"/>
+          <a:lstStyle/>
+          <a:p>
+            <a:pPr marL="0" marR="0" lvl="0" indent="0" algn="ctr" defTabSz="914400" rtl="0" eaLnBrk="1" fontAlgn="auto" latinLnBrk="0" hangingPunct="1">
+              <a:lnSpc>
+                <a:spcPct val="95000"/>
+              </a:lnSpc>
+              <a:spcBef>
+                <a:spcPts val="0"/>
+              </a:spcBef>
+              <a:spcAft>
+                <a:spcPts val="0"/>
+              </a:spcAft>
+              <a:buClrTx/>
+              <a:buSzTx/>
+              <a:buFontTx/>
+              <a:buNone/>
+              <a:tabLst/>
+              <a:defRPr/>
+            </a:pPr>
+            <a:endParaRPr kumimoji="0" lang="en-US" sz="1800" b="1" i="0" u="none" strike="noStrike" kern="1200" cap="none" spc="0" normalizeH="0" baseline="0" noProof="0">
+              <a:ln>
+                <a:noFill/>
+              </a:ln>
+              <a:solidFill>
+                <a:srgbClr val="C9BC9B"/>
+              </a:solidFill>
+              <a:effectLst/>
+              <a:uLnTx/>
+              <a:uFillTx/>
+              <a:latin typeface="Source Sans Pro" panose="020B0503030403020204" pitchFamily="34" charset="0"/>
+              <a:ea typeface="Source Sans Pro" panose="020B0503030403020204" pitchFamily="34" charset="0"/>
+            </a:endParaRPr>
+          </a:p>
+        </p:txBody>
+      </p:sp>
+      <p:sp>
+        <p:nvSpPr>
+          <p:cNvPr id="21" name="Triangle 20">
+            <a:extLst>
+              <a:ext uri="{FF2B5EF4-FFF2-40B4-BE49-F238E27FC236}">
+                <a16:creationId xmlns:a16="http://schemas.microsoft.com/office/drawing/2014/main" id="{EA6090C1-9FA1-5B2D-BB69-15B0C29274F4}"/>
+              </a:ext>
+            </a:extLst>
+          </p:cNvPr>
+          <p:cNvSpPr/>
+          <p:nvPr/>
+        </p:nvSpPr>
+        <p:spPr>
+          <a:xfrm rot="18013776">
+            <a:off x="1993961" y="206877"/>
+            <a:ext cx="1613889" cy="1391283"/>
+          </a:xfrm>
+          <a:prstGeom prst="triangle">
+            <a:avLst/>
+          </a:prstGeom>
+          <a:solidFill>
+            <a:schemeClr val="accent3"/>
+          </a:solidFill>
+          <a:ln>
+            <a:noFill/>
+          </a:ln>
+          <a:effectLst/>
+        </p:spPr>
+        <p:style>
+          <a:lnRef idx="2">
+            <a:schemeClr val="accent1">
+              <a:shade val="50000"/>
+            </a:schemeClr>
+          </a:lnRef>
+          <a:fillRef idx="1">
+            <a:schemeClr val="accent1"/>
+          </a:fillRef>
+          <a:effectRef idx="0">
+            <a:schemeClr val="accent1"/>
+          </a:effectRef>
+          <a:fontRef idx="minor">
+            <a:schemeClr val="lt1"/>
+          </a:fontRef>
+        </p:style>
+        <p:txBody>
+          <a:bodyPr rtlCol="0" anchor="ctr"/>
+          <a:lstStyle/>
+          <a:p>
+            <a:pPr algn="ctr">
+              <a:lnSpc>
+                <a:spcPct val="95000"/>
+              </a:lnSpc>
+            </a:pPr>
+            <a:endParaRPr lang="en-US" b="1" dirty="0">
+              <a:solidFill>
+                <a:schemeClr val="tx2"/>
+              </a:solidFill>
+              <a:latin typeface="+mj-lt"/>
+            </a:endParaRPr>
+          </a:p>
+        </p:txBody>
+      </p:sp>
+      <p:sp>
+        <p:nvSpPr>
+          <p:cNvPr id="23" name="Circular Arrow 22">
+            <a:extLst>
+              <a:ext uri="{FF2B5EF4-FFF2-40B4-BE49-F238E27FC236}">
+                <a16:creationId xmlns:a16="http://schemas.microsoft.com/office/drawing/2014/main" id="{7AB00D11-5787-301F-77B5-673483AB25C6}"/>
+              </a:ext>
+            </a:extLst>
+          </p:cNvPr>
+          <p:cNvSpPr/>
+          <p:nvPr/>
+        </p:nvSpPr>
+        <p:spPr>
+          <a:xfrm rot="12789359" flipH="1">
+            <a:off x="3930321" y="95953"/>
+            <a:ext cx="1944772" cy="1945987"/>
+          </a:xfrm>
+          <a:prstGeom prst="circularArrow">
+            <a:avLst>
+              <a:gd name="adj1" fmla="val 15037"/>
+              <a:gd name="adj2" fmla="val 1142319"/>
+              <a:gd name="adj3" fmla="val 19561631"/>
+              <a:gd name="adj4" fmla="val 17351106"/>
+              <a:gd name="adj5" fmla="val 8364"/>
+            </a:avLst>
+          </a:prstGeom>
+          <a:solidFill>
+            <a:srgbClr val="A44E3C"/>
+          </a:solidFill>
+          <a:ln w="19050">
+            <a:solidFill>
+              <a:schemeClr val="bg1"/>
+            </a:solidFill>
+          </a:ln>
+        </p:spPr>
+        <p:style>
+          <a:lnRef idx="0">
+            <a:scrgbClr r="0" g="0" b="0"/>
+          </a:lnRef>
+          <a:fillRef idx="0">
+            <a:scrgbClr r="0" g="0" b="0"/>
+          </a:fillRef>
+          <a:effectRef idx="0">
+            <a:scrgbClr r="0" g="0" b="0"/>
+          </a:effectRef>
+          <a:fontRef idx="minor">
+            <a:schemeClr val="lt1"/>
+          </a:fontRef>
+        </p:style>
+        <p:txBody>
+          <a:bodyPr rtlCol="0" anchor="ctr"/>
+          <a:lstStyle/>
+          <a:p>
+            <a:pPr marL="0" marR="0" lvl="0" indent="0" algn="ctr" defTabSz="914400" rtl="0" eaLnBrk="1" fontAlgn="auto" latinLnBrk="0" hangingPunct="1">
+              <a:lnSpc>
+                <a:spcPct val="95000"/>
+              </a:lnSpc>
+              <a:spcBef>
+                <a:spcPts val="0"/>
+              </a:spcBef>
+              <a:spcAft>
+                <a:spcPts val="0"/>
+              </a:spcAft>
+              <a:buClrTx/>
+              <a:buSzTx/>
+              <a:buFontTx/>
+              <a:buNone/>
+              <a:tabLst/>
+              <a:defRPr/>
+            </a:pPr>
+            <a:endParaRPr kumimoji="0" lang="en-US" sz="1800" b="1" i="0" u="none" strike="noStrike" kern="1200" cap="none" spc="0" normalizeH="0" baseline="0" noProof="0">
+              <a:ln>
+                <a:noFill/>
+              </a:ln>
+              <a:solidFill>
+                <a:srgbClr val="C9BC9B"/>
+              </a:solidFill>
+              <a:effectLst/>
+              <a:uLnTx/>
+              <a:uFillTx/>
+              <a:latin typeface="Source Sans Pro" panose="020B0503030403020204" pitchFamily="34" charset="0"/>
+              <a:ea typeface="Source Sans Pro" panose="020B0503030403020204" pitchFamily="34" charset="0"/>
+            </a:endParaRPr>
+          </a:p>
+        </p:txBody>
+      </p:sp>
+      <p:sp>
+        <p:nvSpPr>
+          <p:cNvPr id="25" name="Pentagon 24">
+            <a:extLst>
+              <a:ext uri="{FF2B5EF4-FFF2-40B4-BE49-F238E27FC236}">
+                <a16:creationId xmlns:a16="http://schemas.microsoft.com/office/drawing/2014/main" id="{BDB476FF-3451-F2A5-589F-8E2637AA5926}"/>
+              </a:ext>
+            </a:extLst>
+          </p:cNvPr>
+          <p:cNvSpPr/>
+          <p:nvPr/>
+        </p:nvSpPr>
+        <p:spPr>
+          <a:xfrm flipH="1">
+            <a:off x="3037875" y="129571"/>
+            <a:ext cx="1888856" cy="298376"/>
+          </a:xfrm>
+          <a:prstGeom prst="homePlate">
+            <a:avLst/>
+          </a:prstGeom>
+          <a:solidFill>
+            <a:schemeClr val="accent2"/>
+          </a:solidFill>
+          <a:ln w="19050">
+            <a:solidFill>
+              <a:schemeClr val="accent4"/>
+            </a:solidFill>
+          </a:ln>
+          <a:effectLst/>
+        </p:spPr>
+        <p:style>
+          <a:lnRef idx="2">
+            <a:schemeClr val="accent1">
+              <a:shade val="50000"/>
+            </a:schemeClr>
+          </a:lnRef>
+          <a:fillRef idx="1">
+            <a:schemeClr val="accent1"/>
+          </a:fillRef>
+          <a:effectRef idx="0">
+            <a:schemeClr val="accent1"/>
+          </a:effectRef>
+          <a:fontRef idx="minor">
+            <a:schemeClr val="lt1"/>
+          </a:fontRef>
+        </p:style>
+        <p:txBody>
+          <a:bodyPr rtlCol="0" anchor="ctr"/>
+          <a:lstStyle/>
+          <a:p>
+            <a:pPr algn="ctr">
+              <a:lnSpc>
+                <a:spcPct val="95000"/>
+              </a:lnSpc>
+            </a:pPr>
+            <a:endParaRPr lang="en-US" b="1" dirty="0">
+              <a:solidFill>
+                <a:schemeClr val="tx2"/>
+              </a:solidFill>
+              <a:latin typeface="+mj-lt"/>
+            </a:endParaRPr>
+          </a:p>
+        </p:txBody>
+      </p:sp>
+      <p:sp>
+        <p:nvSpPr>
+          <p:cNvPr id="22" name="Pentagon 21">
+            <a:extLst>
+              <a:ext uri="{FF2B5EF4-FFF2-40B4-BE49-F238E27FC236}">
+                <a16:creationId xmlns:a16="http://schemas.microsoft.com/office/drawing/2014/main" id="{94F55B08-3F6B-4BB0-0B91-75999A986E41}"/>
+              </a:ext>
+            </a:extLst>
+          </p:cNvPr>
+          <p:cNvSpPr/>
+          <p:nvPr/>
+        </p:nvSpPr>
+        <p:spPr>
+          <a:xfrm>
+            <a:off x="2967424" y="1710698"/>
+            <a:ext cx="1144273" cy="298376"/>
+          </a:xfrm>
+          <a:prstGeom prst="homePlate">
+            <a:avLst/>
+          </a:prstGeom>
+          <a:solidFill>
+            <a:schemeClr val="accent2"/>
+          </a:solidFill>
+          <a:ln w="19050">
+            <a:solidFill>
+              <a:schemeClr val="accent4"/>
+            </a:solidFill>
+          </a:ln>
+          <a:effectLst/>
+        </p:spPr>
+        <p:style>
+          <a:lnRef idx="2">
+            <a:schemeClr val="accent1">
+              <a:shade val="50000"/>
+            </a:schemeClr>
+          </a:lnRef>
+          <a:fillRef idx="1">
+            <a:schemeClr val="accent1"/>
+          </a:fillRef>
+          <a:effectRef idx="0">
+            <a:schemeClr val="accent1"/>
+          </a:effectRef>
+          <a:fontRef idx="minor">
+            <a:schemeClr val="lt1"/>
+          </a:fontRef>
+        </p:style>
+        <p:txBody>
+          <a:bodyPr rtlCol="0" anchor="ctr"/>
+          <a:lstStyle/>
+          <a:p>
+            <a:pPr algn="ctr">
+              <a:lnSpc>
+                <a:spcPct val="95000"/>
+              </a:lnSpc>
+            </a:pPr>
+            <a:endParaRPr lang="en-US" b="1" dirty="0">
+              <a:solidFill>
+                <a:schemeClr val="tx2"/>
+              </a:solidFill>
+              <a:latin typeface="+mj-lt"/>
+            </a:endParaRPr>
+          </a:p>
+        </p:txBody>
+      </p:sp>
+      <p:sp>
+        <p:nvSpPr>
+          <p:cNvPr id="27" name="Pentagon 26">
+            <a:extLst>
+              <a:ext uri="{FF2B5EF4-FFF2-40B4-BE49-F238E27FC236}">
+                <a16:creationId xmlns:a16="http://schemas.microsoft.com/office/drawing/2014/main" id="{C6CF1405-8434-25E7-DA6D-78E73CAF0A40}"/>
+              </a:ext>
+            </a:extLst>
+          </p:cNvPr>
+          <p:cNvSpPr/>
+          <p:nvPr/>
+        </p:nvSpPr>
+        <p:spPr>
+          <a:xfrm flipH="1">
+            <a:off x="3912325" y="125182"/>
+            <a:ext cx="1024515" cy="298376"/>
+          </a:xfrm>
+          <a:prstGeom prst="homePlate">
+            <a:avLst/>
+          </a:prstGeom>
+          <a:solidFill>
+            <a:schemeClr val="accent2"/>
+          </a:solidFill>
+          <a:ln w="19050">
+            <a:solidFill>
+              <a:schemeClr val="accent4"/>
+            </a:solidFill>
+          </a:ln>
+          <a:effectLst/>
+        </p:spPr>
+        <p:style>
+          <a:lnRef idx="2">
+            <a:schemeClr val="accent1">
+              <a:shade val="50000"/>
+            </a:schemeClr>
+          </a:lnRef>
+          <a:fillRef idx="1">
+            <a:schemeClr val="accent1"/>
+          </a:fillRef>
+          <a:effectRef idx="0">
+            <a:schemeClr val="accent1"/>
+          </a:effectRef>
+          <a:fontRef idx="minor">
+            <a:schemeClr val="lt1"/>
+          </a:fontRef>
+        </p:style>
+        <p:txBody>
+          <a:bodyPr rtlCol="0" anchor="ctr"/>
+          <a:lstStyle/>
+          <a:p>
+            <a:pPr algn="ctr">
+              <a:lnSpc>
+                <a:spcPct val="95000"/>
+              </a:lnSpc>
+            </a:pPr>
+            <a:endParaRPr lang="en-US" b="1" dirty="0">
+              <a:solidFill>
+                <a:schemeClr val="tx2"/>
+              </a:solidFill>
+              <a:latin typeface="+mj-lt"/>
+            </a:endParaRPr>
+          </a:p>
+        </p:txBody>
+      </p:sp>
+    </p:spTree>
+    <p:extLst>
+      <p:ext uri="{BB962C8B-B14F-4D97-AF65-F5344CB8AC3E}">
+        <p14:creationId xmlns:p14="http://schemas.microsoft.com/office/powerpoint/2010/main" val="653240851"/>
+      </p:ext>
+    </p:extLst>
+  </p:cSld>
+  <p:clrMapOvr>
+    <a:masterClrMapping/>
+  </p:clrMapOvr>
+</p:sld>
+</file>
+
+<file path=ppt/slides/slide4.xml><?xml version="1.0" encoding="utf-8"?>
 <p:sld xmlns:a="http://schemas.openxmlformats.org/drawingml/2006/main" xmlns:r="http://schemas.openxmlformats.org/officeDocument/2006/relationships" xmlns:p="http://schemas.openxmlformats.org/presentationml/2006/main">
   <p:cSld>
     <p:spTree>
@@ -7818,33 +10894,286 @@
       </p:grpSpPr>
       <p:sp>
         <p:nvSpPr>
-          <p:cNvPr id="2" name="Title 1">
+          <p:cNvPr id="6" name="Oval 5">
             <a:extLst>
               <a:ext uri="{FF2B5EF4-FFF2-40B4-BE49-F238E27FC236}">
-                <a16:creationId xmlns:a16="http://schemas.microsoft.com/office/drawing/2014/main" id="{7B968D16-9341-EE7F-1E54-05F8E7B8F570}"/>
+                <a16:creationId xmlns:a16="http://schemas.microsoft.com/office/drawing/2014/main" id="{653111D8-3D55-BC7B-42E7-561301B36131}"/>
               </a:ext>
             </a:extLst>
           </p:cNvPr>
-          <p:cNvSpPr>
-            <a:spLocks noGrp="1"/>
-          </p:cNvSpPr>
-          <p:nvPr>
-            <p:ph type="title"/>
-          </p:nvPr>
+          <p:cNvSpPr/>
+          <p:nvPr/>
         </p:nvSpPr>
-        <p:spPr/>
+        <p:spPr>
+          <a:xfrm>
+            <a:off x="3171008" y="738051"/>
+            <a:ext cx="1430383" cy="1430383"/>
+          </a:xfrm>
+          <a:prstGeom prst="ellipse">
+            <a:avLst/>
+          </a:prstGeom>
+          <a:solidFill>
+            <a:schemeClr val="accent3"/>
+          </a:solidFill>
+          <a:ln>
+            <a:noFill/>
+          </a:ln>
+          <a:effectLst>
+            <a:outerShdw dist="38100" dir="5400000" algn="t" rotWithShape="0">
+              <a:schemeClr val="bg2">
+                <a:alpha val="20000"/>
+              </a:schemeClr>
+            </a:outerShdw>
+          </a:effectLst>
+        </p:spPr>
+        <p:style>
+          <a:lnRef idx="2">
+            <a:schemeClr val="accent1">
+              <a:shade val="50000"/>
+            </a:schemeClr>
+          </a:lnRef>
+          <a:fillRef idx="1">
+            <a:schemeClr val="accent1"/>
+          </a:fillRef>
+          <a:effectRef idx="0">
+            <a:schemeClr val="accent1"/>
+          </a:effectRef>
+          <a:fontRef idx="minor">
+            <a:schemeClr val="lt1"/>
+          </a:fontRef>
+        </p:style>
         <p:txBody>
-          <a:bodyPr/>
+          <a:bodyPr rtlCol="0" anchor="ctr"/>
           <a:lstStyle/>
           <a:p>
-            <a:endParaRPr lang="en-US"/>
+            <a:pPr algn="ctr">
+              <a:lnSpc>
+                <a:spcPct val="95000"/>
+              </a:lnSpc>
+            </a:pPr>
+            <a:endParaRPr lang="en-US" b="1" dirty="0">
+              <a:solidFill>
+                <a:schemeClr val="tx2"/>
+              </a:solidFill>
+              <a:latin typeface="+mj-lt"/>
+            </a:endParaRPr>
+          </a:p>
+        </p:txBody>
+      </p:sp>
+      <p:sp>
+        <p:nvSpPr>
+          <p:cNvPr id="3" name="Circular Arrow 2">
+            <a:extLst>
+              <a:ext uri="{FF2B5EF4-FFF2-40B4-BE49-F238E27FC236}">
+                <a16:creationId xmlns:a16="http://schemas.microsoft.com/office/drawing/2014/main" id="{359A3D48-4827-DC5A-6493-5D0CE3B296F2}"/>
+              </a:ext>
+            </a:extLst>
+          </p:cNvPr>
+          <p:cNvSpPr/>
+          <p:nvPr/>
+        </p:nvSpPr>
+        <p:spPr>
+          <a:xfrm rot="10800000" flipH="1">
+            <a:off x="979714" y="663191"/>
+            <a:ext cx="1291213" cy="1291213"/>
+          </a:xfrm>
+          <a:prstGeom prst="circularArrow">
+            <a:avLst>
+              <a:gd name="adj1" fmla="val 12500"/>
+              <a:gd name="adj2" fmla="val 1142319"/>
+              <a:gd name="adj3" fmla="val 20457681"/>
+              <a:gd name="adj4" fmla="val 244163"/>
+              <a:gd name="adj5" fmla="val 12500"/>
+            </a:avLst>
+          </a:prstGeom>
+          <a:solidFill>
+            <a:schemeClr val="accent2"/>
+          </a:solidFill>
+          <a:ln>
+            <a:noFill/>
+          </a:ln>
+          <a:effectLst>
+            <a:outerShdw dist="38100" dir="5400000" algn="t" rotWithShape="0">
+              <a:schemeClr val="bg2">
+                <a:alpha val="20000"/>
+              </a:schemeClr>
+            </a:outerShdw>
+          </a:effectLst>
+        </p:spPr>
+        <p:style>
+          <a:lnRef idx="2">
+            <a:schemeClr val="accent1">
+              <a:shade val="50000"/>
+            </a:schemeClr>
+          </a:lnRef>
+          <a:fillRef idx="1">
+            <a:schemeClr val="accent1"/>
+          </a:fillRef>
+          <a:effectRef idx="0">
+            <a:schemeClr val="accent1"/>
+          </a:effectRef>
+          <a:fontRef idx="minor">
+            <a:schemeClr val="lt1"/>
+          </a:fontRef>
+        </p:style>
+        <p:txBody>
+          <a:bodyPr rtlCol="0" anchor="ctr"/>
+          <a:lstStyle/>
+          <a:p>
+            <a:pPr algn="ctr">
+              <a:lnSpc>
+                <a:spcPct val="95000"/>
+              </a:lnSpc>
+            </a:pPr>
+            <a:endParaRPr lang="en-US" b="1" dirty="0">
+              <a:solidFill>
+                <a:schemeClr val="tx2"/>
+              </a:solidFill>
+              <a:latin typeface="+mj-lt"/>
+            </a:endParaRPr>
+          </a:p>
+        </p:txBody>
+      </p:sp>
+      <p:sp>
+        <p:nvSpPr>
+          <p:cNvPr id="4" name="Circular Arrow 3">
+            <a:extLst>
+              <a:ext uri="{FF2B5EF4-FFF2-40B4-BE49-F238E27FC236}">
+                <a16:creationId xmlns:a16="http://schemas.microsoft.com/office/drawing/2014/main" id="{6A2CC320-BCEB-8120-F806-16C057D60336}"/>
+              </a:ext>
+            </a:extLst>
+          </p:cNvPr>
+          <p:cNvSpPr/>
+          <p:nvPr/>
+        </p:nvSpPr>
+        <p:spPr>
+          <a:xfrm rot="10800000" flipH="1">
+            <a:off x="575267" y="537587"/>
+            <a:ext cx="2100105" cy="2100105"/>
+          </a:xfrm>
+          <a:prstGeom prst="circularArrow">
+            <a:avLst>
+              <a:gd name="adj1" fmla="val 5034"/>
+              <a:gd name="adj2" fmla="val 1142319"/>
+              <a:gd name="adj3" fmla="val 20479250"/>
+              <a:gd name="adj4" fmla="val 244163"/>
+              <a:gd name="adj5" fmla="val 12500"/>
+            </a:avLst>
+          </a:prstGeom>
+          <a:solidFill>
+            <a:schemeClr val="accent3"/>
+          </a:solidFill>
+          <a:ln>
+            <a:noFill/>
+          </a:ln>
+          <a:effectLst>
+            <a:outerShdw dist="38100" dir="5400000" algn="t" rotWithShape="0">
+              <a:schemeClr val="bg2">
+                <a:alpha val="20000"/>
+              </a:schemeClr>
+            </a:outerShdw>
+          </a:effectLst>
+        </p:spPr>
+        <p:style>
+          <a:lnRef idx="2">
+            <a:schemeClr val="accent1">
+              <a:shade val="50000"/>
+            </a:schemeClr>
+          </a:lnRef>
+          <a:fillRef idx="1">
+            <a:schemeClr val="accent1"/>
+          </a:fillRef>
+          <a:effectRef idx="0">
+            <a:schemeClr val="accent1"/>
+          </a:effectRef>
+          <a:fontRef idx="minor">
+            <a:schemeClr val="lt1"/>
+          </a:fontRef>
+        </p:style>
+        <p:txBody>
+          <a:bodyPr rtlCol="0" anchor="ctr"/>
+          <a:lstStyle/>
+          <a:p>
+            <a:pPr algn="ctr">
+              <a:lnSpc>
+                <a:spcPct val="95000"/>
+              </a:lnSpc>
+            </a:pPr>
+            <a:endParaRPr lang="en-US" b="1" dirty="0">
+              <a:solidFill>
+                <a:schemeClr val="tx2"/>
+              </a:solidFill>
+              <a:latin typeface="+mj-lt"/>
+            </a:endParaRPr>
+          </a:p>
+        </p:txBody>
+      </p:sp>
+      <p:sp>
+        <p:nvSpPr>
+          <p:cNvPr id="5" name="Oval 4">
+            <a:extLst>
+              <a:ext uri="{FF2B5EF4-FFF2-40B4-BE49-F238E27FC236}">
+                <a16:creationId xmlns:a16="http://schemas.microsoft.com/office/drawing/2014/main" id="{AE26C73E-3E08-30C3-3C16-0B785EBD8880}"/>
+              </a:ext>
+            </a:extLst>
+          </p:cNvPr>
+          <p:cNvSpPr/>
+          <p:nvPr/>
+        </p:nvSpPr>
+        <p:spPr>
+          <a:xfrm>
+            <a:off x="3507377" y="738051"/>
+            <a:ext cx="692332" cy="692332"/>
+          </a:xfrm>
+          <a:prstGeom prst="ellipse">
+            <a:avLst/>
+          </a:prstGeom>
+          <a:solidFill>
+            <a:schemeClr val="accent2"/>
+          </a:solidFill>
+          <a:ln>
+            <a:noFill/>
+          </a:ln>
+          <a:effectLst/>
+        </p:spPr>
+        <p:style>
+          <a:lnRef idx="2">
+            <a:schemeClr val="accent1">
+              <a:shade val="50000"/>
+            </a:schemeClr>
+          </a:lnRef>
+          <a:fillRef idx="1">
+            <a:schemeClr val="accent1"/>
+          </a:fillRef>
+          <a:effectRef idx="0">
+            <a:schemeClr val="accent1"/>
+          </a:effectRef>
+          <a:fontRef idx="minor">
+            <a:schemeClr val="lt1"/>
+          </a:fontRef>
+        </p:style>
+        <p:txBody>
+          <a:bodyPr rtlCol="0" anchor="ctr"/>
+          <a:lstStyle/>
+          <a:p>
+            <a:pPr algn="ctr">
+              <a:lnSpc>
+                <a:spcPct val="95000"/>
+              </a:lnSpc>
+            </a:pPr>
+            <a:endParaRPr lang="en-US" b="1" dirty="0">
+              <a:solidFill>
+                <a:schemeClr val="tx2"/>
+              </a:solidFill>
+              <a:latin typeface="+mj-lt"/>
+            </a:endParaRPr>
           </a:p>
         </p:txBody>
       </p:sp>
     </p:spTree>
     <p:extLst>
       <p:ext uri="{BB962C8B-B14F-4D97-AF65-F5344CB8AC3E}">
-        <p14:creationId xmlns:p14="http://schemas.microsoft.com/office/powerpoint/2010/main" val="1692443439"/>
+        <p14:creationId xmlns:p14="http://schemas.microsoft.com/office/powerpoint/2010/main" val="1678728573"/>
       </p:ext>
     </p:extLst>
   </p:cSld>

</xml_diff>

<commit_message>
feat: move things in powerpoint, no effect on actual fig
</commit_message>
<xml_diff>
--- a/docs/figures/pptx/continuous-curation-loop.pptx
+++ b/docs/figures/pptx/continuous-curation-loop.pptx
@@ -9573,7 +9573,7 @@
         <p:spPr>
           <a:xfrm>
             <a:off x="3558095" y="1703282"/>
-            <a:ext cx="1144273" cy="298376"/>
+            <a:ext cx="1399045" cy="298376"/>
           </a:xfrm>
           <a:prstGeom prst="homePlate">
             <a:avLst/>
@@ -10748,8 +10748,8 @@
         </p:nvSpPr>
         <p:spPr>
           <a:xfrm>
-            <a:off x="2967424" y="1710698"/>
-            <a:ext cx="1144273" cy="298376"/>
+            <a:off x="3012368" y="1710698"/>
+            <a:ext cx="1099329" cy="298376"/>
           </a:xfrm>
           <a:prstGeom prst="homePlate">
             <a:avLst/>
@@ -11048,7 +11048,7 @@
         </p:nvSpPr>
         <p:spPr>
           <a:xfrm rot="10800000" flipH="1">
-            <a:off x="575267" y="537587"/>
+            <a:off x="669221" y="0"/>
             <a:ext cx="2100105" cy="2100105"/>
           </a:xfrm>
           <a:prstGeom prst="circularArrow">

</xml_diff>